<commit_message>
Finale enhancements in ppt
</commit_message>
<xml_diff>
--- a/Project_AT&T_AH.pptx
+++ b/Project_AT&T_AH.pptx
@@ -5,57 +5,54 @@
     <p:sldMasterId id="2147483659" r:id="rId1"/>
   </p:sldMasterIdLst>
   <p:notesMasterIdLst>
-    <p:notesMasterId r:id="rId19"/>
+    <p:notesMasterId r:id="rId16"/>
   </p:notesMasterIdLst>
   <p:sldIdLst>
     <p:sldId id="256" r:id="rId2"/>
     <p:sldId id="257" r:id="rId3"/>
     <p:sldId id="258" r:id="rId4"/>
     <p:sldId id="266" r:id="rId5"/>
-    <p:sldId id="267" r:id="rId6"/>
-    <p:sldId id="271" r:id="rId7"/>
-    <p:sldId id="263" r:id="rId8"/>
-    <p:sldId id="269" r:id="rId9"/>
-    <p:sldId id="272" r:id="rId10"/>
-    <p:sldId id="270" r:id="rId11"/>
-    <p:sldId id="273" r:id="rId12"/>
-    <p:sldId id="274" r:id="rId13"/>
-    <p:sldId id="265" r:id="rId14"/>
-    <p:sldId id="275" r:id="rId15"/>
-    <p:sldId id="276" r:id="rId16"/>
-    <p:sldId id="261" r:id="rId17"/>
-    <p:sldId id="262" r:id="rId18"/>
+    <p:sldId id="271" r:id="rId6"/>
+    <p:sldId id="263" r:id="rId7"/>
+    <p:sldId id="269" r:id="rId8"/>
+    <p:sldId id="270" r:id="rId9"/>
+    <p:sldId id="274" r:id="rId10"/>
+    <p:sldId id="265" r:id="rId11"/>
+    <p:sldId id="275" r:id="rId12"/>
+    <p:sldId id="276" r:id="rId13"/>
+    <p:sldId id="261" r:id="rId14"/>
+    <p:sldId id="262" r:id="rId15"/>
   </p:sldIdLst>
   <p:sldSz cx="9144000" cy="5143500" type="screen16x9"/>
   <p:notesSz cx="6858000" cy="9144000"/>
   <p:embeddedFontLst>
     <p:embeddedFont>
       <p:font typeface="Inter" panose="020B0604020202020204" charset="0"/>
-      <p:regular r:id="rId20"/>
-      <p:bold r:id="rId21"/>
-      <p:italic r:id="rId22"/>
-      <p:boldItalic r:id="rId23"/>
+      <p:regular r:id="rId17"/>
+      <p:bold r:id="rId18"/>
+      <p:italic r:id="rId19"/>
+      <p:boldItalic r:id="rId20"/>
     </p:embeddedFont>
     <p:embeddedFont>
       <p:font typeface="Inter Medium" panose="020B0604020202020204" charset="0"/>
-      <p:regular r:id="rId24"/>
-      <p:bold r:id="rId25"/>
-      <p:italic r:id="rId26"/>
-      <p:boldItalic r:id="rId27"/>
+      <p:regular r:id="rId21"/>
+      <p:bold r:id="rId22"/>
+      <p:italic r:id="rId23"/>
+      <p:boldItalic r:id="rId24"/>
     </p:embeddedFont>
     <p:embeddedFont>
       <p:font typeface="Inter SemiBold" panose="020B0604020202020204" charset="0"/>
-      <p:regular r:id="rId28"/>
-      <p:bold r:id="rId29"/>
-      <p:italic r:id="rId30"/>
-      <p:boldItalic r:id="rId31"/>
+      <p:regular r:id="rId25"/>
+      <p:bold r:id="rId26"/>
+      <p:italic r:id="rId27"/>
+      <p:boldItalic r:id="rId28"/>
     </p:embeddedFont>
     <p:embeddedFont>
       <p:font typeface="Libre Baskerville" panose="02000000000000000000" pitchFamily="2" charset="0"/>
-      <p:regular r:id="rId32"/>
-      <p:bold r:id="rId33"/>
-      <p:italic r:id="rId34"/>
-      <p:boldItalic r:id="rId35"/>
+      <p:regular r:id="rId29"/>
+      <p:bold r:id="rId30"/>
+      <p:italic r:id="rId31"/>
+      <p:boldItalic r:id="rId32"/>
     </p:embeddedFont>
   </p:embeddedFontLst>
   <p:defaultTextStyle>
@@ -848,600 +845,6 @@
         <p:cNvPr id="1" name="Shape 77">
           <a:extLst>
             <a:ext uri="{FF2B5EF4-FFF2-40B4-BE49-F238E27FC236}">
-              <a16:creationId xmlns:a16="http://schemas.microsoft.com/office/drawing/2014/main" id="{DE1F163D-9306-B63B-8A42-5A1B6E71D6FC}"/>
-            </a:ext>
-          </a:extLst>
-        </p:cNvPr>
-        <p:cNvGrpSpPr/>
-        <p:nvPr/>
-      </p:nvGrpSpPr>
-      <p:grpSpPr>
-        <a:xfrm>
-          <a:off x="0" y="0"/>
-          <a:ext cx="0" cy="0"/>
-          <a:chOff x="0" y="0"/>
-          <a:chExt cx="0" cy="0"/>
-        </a:xfrm>
-      </p:grpSpPr>
-      <p:sp>
-        <p:nvSpPr>
-          <p:cNvPr id="78" name="Google Shape;78;gf4f11f959e_0_5:notes">
-            <a:extLst>
-              <a:ext uri="{FF2B5EF4-FFF2-40B4-BE49-F238E27FC236}">
-                <a16:creationId xmlns:a16="http://schemas.microsoft.com/office/drawing/2014/main" id="{A44DE11A-7589-D211-54C0-A40875A23DA1}"/>
-              </a:ext>
-            </a:extLst>
-          </p:cNvPr>
-          <p:cNvSpPr>
-            <a:spLocks noGrp="1" noRot="1" noChangeAspect="1"/>
-          </p:cNvSpPr>
-          <p:nvPr>
-            <p:ph type="sldImg" idx="2"/>
-          </p:nvPr>
-        </p:nvSpPr>
-        <p:spPr>
-          <a:xfrm>
-            <a:off x="381000" y="685800"/>
-            <a:ext cx="6096000" cy="3429000"/>
-          </a:xfrm>
-          <a:custGeom>
-            <a:avLst/>
-            <a:gdLst/>
-            <a:ahLst/>
-            <a:cxnLst/>
-            <a:rect l="l" t="t" r="r" b="b"/>
-            <a:pathLst>
-              <a:path w="120000" h="120000" extrusionOk="0">
-                <a:moveTo>
-                  <a:pt x="0" y="0"/>
-                </a:moveTo>
-                <a:lnTo>
-                  <a:pt x="120000" y="0"/>
-                </a:lnTo>
-                <a:lnTo>
-                  <a:pt x="120000" y="120000"/>
-                </a:lnTo>
-                <a:lnTo>
-                  <a:pt x="0" y="120000"/>
-                </a:lnTo>
-                <a:close/>
-              </a:path>
-            </a:pathLst>
-          </a:custGeom>
-          <a:noFill/>
-          <a:ln w="9525" cap="flat" cmpd="sng">
-            <a:solidFill>
-              <a:srgbClr val="000000"/>
-            </a:solidFill>
-            <a:prstDash val="solid"/>
-            <a:round/>
-            <a:headEnd type="none" w="sm" len="sm"/>
-            <a:tailEnd type="none" w="sm" len="sm"/>
-          </a:ln>
-        </p:spPr>
-      </p:sp>
-      <p:sp>
-        <p:nvSpPr>
-          <p:cNvPr id="79" name="Google Shape;79;gf4f11f959e_0_5:notes">
-            <a:extLst>
-              <a:ext uri="{FF2B5EF4-FFF2-40B4-BE49-F238E27FC236}">
-                <a16:creationId xmlns:a16="http://schemas.microsoft.com/office/drawing/2014/main" id="{D530E629-5E77-0266-BA72-704E4E7606B0}"/>
-              </a:ext>
-            </a:extLst>
-          </p:cNvPr>
-          <p:cNvSpPr txBox="1">
-            <a:spLocks noGrp="1"/>
-          </p:cNvSpPr>
-          <p:nvPr>
-            <p:ph type="body" idx="1"/>
-          </p:nvPr>
-        </p:nvSpPr>
-        <p:spPr>
-          <a:xfrm>
-            <a:off x="685800" y="4343400"/>
-            <a:ext cx="5486400" cy="4114800"/>
-          </a:xfrm>
-          <a:prstGeom prst="rect">
-            <a:avLst/>
-          </a:prstGeom>
-          <a:noFill/>
-          <a:ln>
-            <a:noFill/>
-          </a:ln>
-        </p:spPr>
-        <p:txBody>
-          <a:bodyPr spcFirstLastPara="1" wrap="square" lIns="91425" tIns="91425" rIns="91425" bIns="91425" anchor="t" anchorCtr="0">
-            <a:noAutofit/>
-          </a:bodyPr>
-          <a:lstStyle/>
-          <a:p>
-            <a:pPr marL="0" lvl="0" indent="0" algn="l" rtl="0">
-              <a:lnSpc>
-                <a:spcPct val="100000"/>
-              </a:lnSpc>
-              <a:spcBef>
-                <a:spcPts val="0"/>
-              </a:spcBef>
-              <a:spcAft>
-                <a:spcPts val="0"/>
-              </a:spcAft>
-              <a:buSzPts val="1100"/>
-              <a:buNone/>
-            </a:pPr>
-            <a:r>
-              <a:rPr lang="fr-FR" sz="1100" b="1" dirty="0" err="1"/>
-              <a:t>SimpleSpamDetector</a:t>
-            </a:r>
-            <a:r>
-              <a:rPr lang="fr-FR" sz="1100" b="1" dirty="0"/>
-              <a:t>: </a:t>
-            </a:r>
-            <a:r>
-              <a:rPr lang="fr-FR" sz="1100" dirty="0" err="1"/>
-              <a:t>Purpose</a:t>
-            </a:r>
-            <a:r>
-              <a:rPr lang="fr-FR" sz="1100" dirty="0"/>
-              <a:t>: A </a:t>
-            </a:r>
-            <a:r>
-              <a:rPr lang="fr-FR" sz="1100" dirty="0" err="1"/>
-              <a:t>foundational</a:t>
-            </a:r>
-            <a:r>
-              <a:rPr lang="fr-FR" sz="1100" dirty="0"/>
-              <a:t> model to </a:t>
-            </a:r>
-            <a:r>
-              <a:rPr lang="fr-FR" sz="1100" dirty="0" err="1"/>
-              <a:t>leverage</a:t>
-            </a:r>
-            <a:r>
-              <a:rPr lang="fr-FR" sz="1100" dirty="0"/>
-              <a:t> the </a:t>
-            </a:r>
-            <a:r>
-              <a:rPr lang="fr-FR" sz="1100" dirty="0" err="1"/>
-              <a:t>combined</a:t>
-            </a:r>
-            <a:r>
-              <a:rPr lang="fr-FR" sz="1100" dirty="0"/>
-              <a:t> </a:t>
-            </a:r>
-            <a:r>
-              <a:rPr lang="fr-FR" sz="1100" dirty="0" err="1"/>
-              <a:t>semantic</a:t>
-            </a:r>
-            <a:r>
-              <a:rPr lang="fr-FR" sz="1100" dirty="0"/>
-              <a:t> </a:t>
-            </a:r>
-            <a:r>
-              <a:rPr lang="fr-FR" sz="1100" dirty="0" err="1"/>
-              <a:t>embeddings</a:t>
-            </a:r>
-            <a:r>
-              <a:rPr lang="fr-FR" sz="1100" dirty="0"/>
-              <a:t> and </a:t>
-            </a:r>
-            <a:r>
-              <a:rPr lang="fr-FR" sz="1100" dirty="0" err="1"/>
-              <a:t>engineered</a:t>
-            </a:r>
-            <a:r>
-              <a:rPr lang="fr-FR" sz="1100" dirty="0"/>
-              <a:t> </a:t>
-            </a:r>
-            <a:r>
-              <a:rPr lang="fr-FR" sz="1100" dirty="0" err="1"/>
-              <a:t>features</a:t>
-            </a:r>
-            <a:r>
-              <a:rPr lang="fr-FR" sz="1100" dirty="0"/>
-              <a:t>.</a:t>
-            </a:r>
-          </a:p>
-          <a:p>
-            <a:pPr marL="0" lvl="0" indent="0" algn="l" rtl="0">
-              <a:lnSpc>
-                <a:spcPct val="100000"/>
-              </a:lnSpc>
-              <a:spcBef>
-                <a:spcPts val="0"/>
-              </a:spcBef>
-              <a:spcAft>
-                <a:spcPts val="0"/>
-              </a:spcAft>
-              <a:buSzPts val="1100"/>
-              <a:buNone/>
-            </a:pPr>
-            <a:endParaRPr lang="fr-FR" sz="1100" dirty="0"/>
-          </a:p>
-          <a:p>
-            <a:pPr marL="0" lvl="0" indent="0" algn="l" rtl="0">
-              <a:lnSpc>
-                <a:spcPct val="100000"/>
-              </a:lnSpc>
-              <a:spcBef>
-                <a:spcPts val="0"/>
-              </a:spcBef>
-              <a:spcAft>
-                <a:spcPts val="0"/>
-              </a:spcAft>
-              <a:buSzPts val="1100"/>
-              <a:buNone/>
-            </a:pPr>
-            <a:r>
-              <a:rPr lang="fr-FR" sz="1100" b="1" dirty="0" err="1"/>
-              <a:t>UltraSimpleSpamDetector</a:t>
-            </a:r>
-            <a:r>
-              <a:rPr lang="fr-FR" sz="1100" b="1" dirty="0"/>
-              <a:t>: </a:t>
-            </a:r>
-            <a:r>
-              <a:rPr lang="fr-FR" sz="1100" dirty="0" err="1"/>
-              <a:t>Purpose</a:t>
-            </a:r>
-            <a:r>
-              <a:rPr lang="fr-FR" sz="1100" dirty="0"/>
-              <a:t>: A </a:t>
-            </a:r>
-            <a:r>
-              <a:rPr lang="fr-FR" sz="1100" dirty="0" err="1"/>
-              <a:t>highly</a:t>
-            </a:r>
-            <a:r>
-              <a:rPr lang="fr-FR" sz="1100" dirty="0"/>
-              <a:t> efficient, minimal model </a:t>
-            </a:r>
-            <a:r>
-              <a:rPr lang="fr-FR" sz="1100" dirty="0" err="1"/>
-              <a:t>designed</a:t>
-            </a:r>
-            <a:r>
-              <a:rPr lang="fr-FR" sz="1100" dirty="0"/>
-              <a:t> for </a:t>
-            </a:r>
-            <a:r>
-              <a:rPr lang="fr-FR" sz="1100" dirty="0" err="1"/>
-              <a:t>faster</a:t>
-            </a:r>
-            <a:r>
-              <a:rPr lang="fr-FR" sz="1100" dirty="0"/>
-              <a:t> training and </a:t>
-            </a:r>
-            <a:r>
-              <a:rPr lang="fr-FR" sz="1100" dirty="0" err="1"/>
-              <a:t>deployment</a:t>
-            </a:r>
-            <a:r>
-              <a:rPr lang="fr-FR" sz="1100" dirty="0"/>
-              <a:t> </a:t>
-            </a:r>
-            <a:r>
-              <a:rPr lang="fr-FR" sz="1100" dirty="0" err="1"/>
-              <a:t>with</a:t>
-            </a:r>
-            <a:r>
-              <a:rPr lang="fr-FR" sz="1100" dirty="0"/>
-              <a:t> comparable performance.</a:t>
-            </a:r>
-            <a:endParaRPr dirty="0"/>
-          </a:p>
-        </p:txBody>
-      </p:sp>
-    </p:spTree>
-    <p:extLst>
-      <p:ext uri="{BB962C8B-B14F-4D97-AF65-F5344CB8AC3E}">
-        <p14:creationId xmlns:p14="http://schemas.microsoft.com/office/powerpoint/2010/main" val="353194640"/>
-      </p:ext>
-    </p:extLst>
-  </p:cSld>
-  <p:clrMapOvr>
-    <a:masterClrMapping/>
-  </p:clrMapOvr>
-</p:notes>
-</file>
-
-<file path=ppt/notesSlides/notesSlide11.xml><?xml version="1.0" encoding="utf-8"?>
-<p:notes xmlns:a="http://schemas.openxmlformats.org/drawingml/2006/main" xmlns:r="http://schemas.openxmlformats.org/officeDocument/2006/relationships" xmlns:p="http://schemas.openxmlformats.org/presentationml/2006/main" showMasterSp="0" showMasterPhAnim="0">
-  <p:cSld>
-    <p:spTree>
-      <p:nvGrpSpPr>
-        <p:cNvPr id="1" name="Shape 77">
-          <a:extLst>
-            <a:ext uri="{FF2B5EF4-FFF2-40B4-BE49-F238E27FC236}">
-              <a16:creationId xmlns:a16="http://schemas.microsoft.com/office/drawing/2014/main" id="{5FBAD69E-1856-3286-A896-3BCF5F5D3D11}"/>
-            </a:ext>
-          </a:extLst>
-        </p:cNvPr>
-        <p:cNvGrpSpPr/>
-        <p:nvPr/>
-      </p:nvGrpSpPr>
-      <p:grpSpPr>
-        <a:xfrm>
-          <a:off x="0" y="0"/>
-          <a:ext cx="0" cy="0"/>
-          <a:chOff x="0" y="0"/>
-          <a:chExt cx="0" cy="0"/>
-        </a:xfrm>
-      </p:grpSpPr>
-      <p:sp>
-        <p:nvSpPr>
-          <p:cNvPr id="78" name="Google Shape;78;gf4f11f959e_0_5:notes">
-            <a:extLst>
-              <a:ext uri="{FF2B5EF4-FFF2-40B4-BE49-F238E27FC236}">
-                <a16:creationId xmlns:a16="http://schemas.microsoft.com/office/drawing/2014/main" id="{2F1C803E-F844-C007-5F15-5676B99F3BAF}"/>
-              </a:ext>
-            </a:extLst>
-          </p:cNvPr>
-          <p:cNvSpPr>
-            <a:spLocks noGrp="1" noRot="1" noChangeAspect="1"/>
-          </p:cNvSpPr>
-          <p:nvPr>
-            <p:ph type="sldImg" idx="2"/>
-          </p:nvPr>
-        </p:nvSpPr>
-        <p:spPr>
-          <a:xfrm>
-            <a:off x="381000" y="685800"/>
-            <a:ext cx="6096000" cy="3429000"/>
-          </a:xfrm>
-          <a:custGeom>
-            <a:avLst/>
-            <a:gdLst/>
-            <a:ahLst/>
-            <a:cxnLst/>
-            <a:rect l="l" t="t" r="r" b="b"/>
-            <a:pathLst>
-              <a:path w="120000" h="120000" extrusionOk="0">
-                <a:moveTo>
-                  <a:pt x="0" y="0"/>
-                </a:moveTo>
-                <a:lnTo>
-                  <a:pt x="120000" y="0"/>
-                </a:lnTo>
-                <a:lnTo>
-                  <a:pt x="120000" y="120000"/>
-                </a:lnTo>
-                <a:lnTo>
-                  <a:pt x="0" y="120000"/>
-                </a:lnTo>
-                <a:close/>
-              </a:path>
-            </a:pathLst>
-          </a:custGeom>
-          <a:noFill/>
-          <a:ln w="9525" cap="flat" cmpd="sng">
-            <a:solidFill>
-              <a:srgbClr val="000000"/>
-            </a:solidFill>
-            <a:prstDash val="solid"/>
-            <a:round/>
-            <a:headEnd type="none" w="sm" len="sm"/>
-            <a:tailEnd type="none" w="sm" len="sm"/>
-          </a:ln>
-        </p:spPr>
-      </p:sp>
-      <p:sp>
-        <p:nvSpPr>
-          <p:cNvPr id="79" name="Google Shape;79;gf4f11f959e_0_5:notes">
-            <a:extLst>
-              <a:ext uri="{FF2B5EF4-FFF2-40B4-BE49-F238E27FC236}">
-                <a16:creationId xmlns:a16="http://schemas.microsoft.com/office/drawing/2014/main" id="{EB2AC066-9B5E-7E46-B2EC-62943BB41ECD}"/>
-              </a:ext>
-            </a:extLst>
-          </p:cNvPr>
-          <p:cNvSpPr txBox="1">
-            <a:spLocks noGrp="1"/>
-          </p:cNvSpPr>
-          <p:nvPr>
-            <p:ph type="body" idx="1"/>
-          </p:nvPr>
-        </p:nvSpPr>
-        <p:spPr>
-          <a:xfrm>
-            <a:off x="685800" y="4343400"/>
-            <a:ext cx="5486400" cy="4114800"/>
-          </a:xfrm>
-          <a:prstGeom prst="rect">
-            <a:avLst/>
-          </a:prstGeom>
-          <a:noFill/>
-          <a:ln>
-            <a:noFill/>
-          </a:ln>
-        </p:spPr>
-        <p:txBody>
-          <a:bodyPr spcFirstLastPara="1" wrap="square" lIns="91425" tIns="91425" rIns="91425" bIns="91425" anchor="t" anchorCtr="0">
-            <a:noAutofit/>
-          </a:bodyPr>
-          <a:lstStyle/>
-          <a:p>
-            <a:pPr marL="0" lvl="0" indent="0" algn="l" rtl="0">
-              <a:lnSpc>
-                <a:spcPct val="100000"/>
-              </a:lnSpc>
-              <a:spcBef>
-                <a:spcPts val="0"/>
-              </a:spcBef>
-              <a:spcAft>
-                <a:spcPts val="0"/>
-              </a:spcAft>
-              <a:buSzPts val="1100"/>
-              <a:buNone/>
-            </a:pPr>
-            <a:endParaRPr/>
-          </a:p>
-        </p:txBody>
-      </p:sp>
-    </p:spTree>
-    <p:extLst>
-      <p:ext uri="{BB962C8B-B14F-4D97-AF65-F5344CB8AC3E}">
-        <p14:creationId xmlns:p14="http://schemas.microsoft.com/office/powerpoint/2010/main" val="3066301346"/>
-      </p:ext>
-    </p:extLst>
-  </p:cSld>
-  <p:clrMapOvr>
-    <a:masterClrMapping/>
-  </p:clrMapOvr>
-</p:notes>
-</file>
-
-<file path=ppt/notesSlides/notesSlide12.xml><?xml version="1.0" encoding="utf-8"?>
-<p:notes xmlns:a="http://schemas.openxmlformats.org/drawingml/2006/main" xmlns:r="http://schemas.openxmlformats.org/officeDocument/2006/relationships" xmlns:p="http://schemas.openxmlformats.org/presentationml/2006/main" showMasterSp="0" showMasterPhAnim="0">
-  <p:cSld>
-    <p:spTree>
-      <p:nvGrpSpPr>
-        <p:cNvPr id="1" name="Shape 77">
-          <a:extLst>
-            <a:ext uri="{FF2B5EF4-FFF2-40B4-BE49-F238E27FC236}">
-              <a16:creationId xmlns:a16="http://schemas.microsoft.com/office/drawing/2014/main" id="{E66714CB-0328-AADF-7A6C-F2EED746642A}"/>
-            </a:ext>
-          </a:extLst>
-        </p:cNvPr>
-        <p:cNvGrpSpPr/>
-        <p:nvPr/>
-      </p:nvGrpSpPr>
-      <p:grpSpPr>
-        <a:xfrm>
-          <a:off x="0" y="0"/>
-          <a:ext cx="0" cy="0"/>
-          <a:chOff x="0" y="0"/>
-          <a:chExt cx="0" cy="0"/>
-        </a:xfrm>
-      </p:grpSpPr>
-      <p:sp>
-        <p:nvSpPr>
-          <p:cNvPr id="78" name="Google Shape;78;gf4f11f959e_0_5:notes">
-            <a:extLst>
-              <a:ext uri="{FF2B5EF4-FFF2-40B4-BE49-F238E27FC236}">
-                <a16:creationId xmlns:a16="http://schemas.microsoft.com/office/drawing/2014/main" id="{4409C3C1-FA78-E144-2871-CB6AF5B64587}"/>
-              </a:ext>
-            </a:extLst>
-          </p:cNvPr>
-          <p:cNvSpPr>
-            <a:spLocks noGrp="1" noRot="1" noChangeAspect="1"/>
-          </p:cNvSpPr>
-          <p:nvPr>
-            <p:ph type="sldImg" idx="2"/>
-          </p:nvPr>
-        </p:nvSpPr>
-        <p:spPr>
-          <a:xfrm>
-            <a:off x="381000" y="685800"/>
-            <a:ext cx="6096000" cy="3429000"/>
-          </a:xfrm>
-          <a:custGeom>
-            <a:avLst/>
-            <a:gdLst/>
-            <a:ahLst/>
-            <a:cxnLst/>
-            <a:rect l="l" t="t" r="r" b="b"/>
-            <a:pathLst>
-              <a:path w="120000" h="120000" extrusionOk="0">
-                <a:moveTo>
-                  <a:pt x="0" y="0"/>
-                </a:moveTo>
-                <a:lnTo>
-                  <a:pt x="120000" y="0"/>
-                </a:lnTo>
-                <a:lnTo>
-                  <a:pt x="120000" y="120000"/>
-                </a:lnTo>
-                <a:lnTo>
-                  <a:pt x="0" y="120000"/>
-                </a:lnTo>
-                <a:close/>
-              </a:path>
-            </a:pathLst>
-          </a:custGeom>
-          <a:noFill/>
-          <a:ln w="9525" cap="flat" cmpd="sng">
-            <a:solidFill>
-              <a:srgbClr val="000000"/>
-            </a:solidFill>
-            <a:prstDash val="solid"/>
-            <a:round/>
-            <a:headEnd type="none" w="sm" len="sm"/>
-            <a:tailEnd type="none" w="sm" len="sm"/>
-          </a:ln>
-        </p:spPr>
-      </p:sp>
-      <p:sp>
-        <p:nvSpPr>
-          <p:cNvPr id="79" name="Google Shape;79;gf4f11f959e_0_5:notes">
-            <a:extLst>
-              <a:ext uri="{FF2B5EF4-FFF2-40B4-BE49-F238E27FC236}">
-                <a16:creationId xmlns:a16="http://schemas.microsoft.com/office/drawing/2014/main" id="{2292C057-74F5-AC0B-F0A1-A7CE21EEA999}"/>
-              </a:ext>
-            </a:extLst>
-          </p:cNvPr>
-          <p:cNvSpPr txBox="1">
-            <a:spLocks noGrp="1"/>
-          </p:cNvSpPr>
-          <p:nvPr>
-            <p:ph type="body" idx="1"/>
-          </p:nvPr>
-        </p:nvSpPr>
-        <p:spPr>
-          <a:xfrm>
-            <a:off x="685800" y="4343400"/>
-            <a:ext cx="5486400" cy="4114800"/>
-          </a:xfrm>
-          <a:prstGeom prst="rect">
-            <a:avLst/>
-          </a:prstGeom>
-          <a:noFill/>
-          <a:ln>
-            <a:noFill/>
-          </a:ln>
-        </p:spPr>
-        <p:txBody>
-          <a:bodyPr spcFirstLastPara="1" wrap="square" lIns="91425" tIns="91425" rIns="91425" bIns="91425" anchor="t" anchorCtr="0">
-            <a:noAutofit/>
-          </a:bodyPr>
-          <a:lstStyle/>
-          <a:p>
-            <a:pPr marL="0" lvl="0" indent="0" algn="l" rtl="0">
-              <a:lnSpc>
-                <a:spcPct val="100000"/>
-              </a:lnSpc>
-              <a:spcBef>
-                <a:spcPts val="0"/>
-              </a:spcBef>
-              <a:spcAft>
-                <a:spcPts val="0"/>
-              </a:spcAft>
-              <a:buSzPts val="1100"/>
-              <a:buNone/>
-            </a:pPr>
-            <a:endParaRPr/>
-          </a:p>
-        </p:txBody>
-      </p:sp>
-    </p:spTree>
-    <p:extLst>
-      <p:ext uri="{BB962C8B-B14F-4D97-AF65-F5344CB8AC3E}">
-        <p14:creationId xmlns:p14="http://schemas.microsoft.com/office/powerpoint/2010/main" val="3052372965"/>
-      </p:ext>
-    </p:extLst>
-  </p:cSld>
-  <p:clrMapOvr>
-    <a:masterClrMapping/>
-  </p:clrMapOvr>
-</p:notes>
-</file>
-
-<file path=ppt/notesSlides/notesSlide13.xml><?xml version="1.0" encoding="utf-8"?>
-<p:notes xmlns:a="http://schemas.openxmlformats.org/drawingml/2006/main" xmlns:r="http://schemas.openxmlformats.org/officeDocument/2006/relationships" xmlns:p="http://schemas.openxmlformats.org/presentationml/2006/main" showMasterSp="0" showMasterPhAnim="0">
-  <p:cSld>
-    <p:spTree>
-      <p:nvGrpSpPr>
-        <p:cNvPr id="1" name="Shape 77">
-          <a:extLst>
-            <a:ext uri="{FF2B5EF4-FFF2-40B4-BE49-F238E27FC236}">
               <a16:creationId xmlns:a16="http://schemas.microsoft.com/office/drawing/2014/main" id="{061283EF-166A-B1E5-9609-6D2ABD40DA5E}"/>
             </a:ext>
           </a:extLst>
@@ -1609,7 +1012,7 @@
 </p:notes>
 </file>
 
-<file path=ppt/notesSlides/notesSlide14.xml><?xml version="1.0" encoding="utf-8"?>
+<file path=ppt/notesSlides/notesSlide11.xml><?xml version="1.0" encoding="utf-8"?>
 <p:notes xmlns:a="http://schemas.openxmlformats.org/drawingml/2006/main" xmlns:r="http://schemas.openxmlformats.org/officeDocument/2006/relationships" xmlns:p="http://schemas.openxmlformats.org/presentationml/2006/main" showMasterSp="0" showMasterPhAnim="0">
   <p:cSld>
     <p:spTree>
@@ -1754,7 +1157,7 @@
 </p:notes>
 </file>
 
-<file path=ppt/notesSlides/notesSlide15.xml><?xml version="1.0" encoding="utf-8"?>
+<file path=ppt/notesSlides/notesSlide12.xml><?xml version="1.0" encoding="utf-8"?>
 <p:notes xmlns:a="http://schemas.openxmlformats.org/drawingml/2006/main" xmlns:r="http://schemas.openxmlformats.org/officeDocument/2006/relationships" xmlns:p="http://schemas.openxmlformats.org/presentationml/2006/main" showMasterSp="0" showMasterPhAnim="0">
   <p:cSld>
     <p:spTree>
@@ -1899,7 +1302,7 @@
 </p:notes>
 </file>
 
-<file path=ppt/notesSlides/notesSlide16.xml><?xml version="1.0" encoding="utf-8"?>
+<file path=ppt/notesSlides/notesSlide13.xml><?xml version="1.0" encoding="utf-8"?>
 <p:notes xmlns:a="http://schemas.openxmlformats.org/drawingml/2006/main" xmlns:r="http://schemas.openxmlformats.org/officeDocument/2006/relationships" xmlns:p="http://schemas.openxmlformats.org/presentationml/2006/main" showMasterSp="0" showMasterPhAnim="0">
   <p:cSld>
     <p:spTree>
@@ -2021,7 +1424,7 @@
 </p:notes>
 </file>
 
-<file path=ppt/notesSlides/notesSlide17.xml><?xml version="1.0" encoding="utf-8"?>
+<file path=ppt/notesSlides/notesSlide14.xml><?xml version="1.0" encoding="utf-8"?>
 <p:notes xmlns:a="http://schemas.openxmlformats.org/drawingml/2006/main" xmlns:r="http://schemas.openxmlformats.org/officeDocument/2006/relationships" xmlns:p="http://schemas.openxmlformats.org/presentationml/2006/main" showMasterSp="0" showMasterPhAnim="0">
   <p:cSld>
     <p:spTree>
@@ -2486,151 +1889,6 @@
         <p:cNvPr id="1" name="Shape 77">
           <a:extLst>
             <a:ext uri="{FF2B5EF4-FFF2-40B4-BE49-F238E27FC236}">
-              <a16:creationId xmlns:a16="http://schemas.microsoft.com/office/drawing/2014/main" id="{D844353A-E0F5-A023-B1C9-419085574A06}"/>
-            </a:ext>
-          </a:extLst>
-        </p:cNvPr>
-        <p:cNvGrpSpPr/>
-        <p:nvPr/>
-      </p:nvGrpSpPr>
-      <p:grpSpPr>
-        <a:xfrm>
-          <a:off x="0" y="0"/>
-          <a:ext cx="0" cy="0"/>
-          <a:chOff x="0" y="0"/>
-          <a:chExt cx="0" cy="0"/>
-        </a:xfrm>
-      </p:grpSpPr>
-      <p:sp>
-        <p:nvSpPr>
-          <p:cNvPr id="78" name="Google Shape;78;gf4f11f959e_0_5:notes">
-            <a:extLst>
-              <a:ext uri="{FF2B5EF4-FFF2-40B4-BE49-F238E27FC236}">
-                <a16:creationId xmlns:a16="http://schemas.microsoft.com/office/drawing/2014/main" id="{1CAB6C14-9E7B-45A3-8E0C-622F7CF7C86D}"/>
-              </a:ext>
-            </a:extLst>
-          </p:cNvPr>
-          <p:cNvSpPr>
-            <a:spLocks noGrp="1" noRot="1" noChangeAspect="1"/>
-          </p:cNvSpPr>
-          <p:nvPr>
-            <p:ph type="sldImg" idx="2"/>
-          </p:nvPr>
-        </p:nvSpPr>
-        <p:spPr>
-          <a:xfrm>
-            <a:off x="381000" y="685800"/>
-            <a:ext cx="6096000" cy="3429000"/>
-          </a:xfrm>
-          <a:custGeom>
-            <a:avLst/>
-            <a:gdLst/>
-            <a:ahLst/>
-            <a:cxnLst/>
-            <a:rect l="l" t="t" r="r" b="b"/>
-            <a:pathLst>
-              <a:path w="120000" h="120000" extrusionOk="0">
-                <a:moveTo>
-                  <a:pt x="0" y="0"/>
-                </a:moveTo>
-                <a:lnTo>
-                  <a:pt x="120000" y="0"/>
-                </a:lnTo>
-                <a:lnTo>
-                  <a:pt x="120000" y="120000"/>
-                </a:lnTo>
-                <a:lnTo>
-                  <a:pt x="0" y="120000"/>
-                </a:lnTo>
-                <a:close/>
-              </a:path>
-            </a:pathLst>
-          </a:custGeom>
-          <a:noFill/>
-          <a:ln w="9525" cap="flat" cmpd="sng">
-            <a:solidFill>
-              <a:srgbClr val="000000"/>
-            </a:solidFill>
-            <a:prstDash val="solid"/>
-            <a:round/>
-            <a:headEnd type="none" w="sm" len="sm"/>
-            <a:tailEnd type="none" w="sm" len="sm"/>
-          </a:ln>
-        </p:spPr>
-      </p:sp>
-      <p:sp>
-        <p:nvSpPr>
-          <p:cNvPr id="79" name="Google Shape;79;gf4f11f959e_0_5:notes">
-            <a:extLst>
-              <a:ext uri="{FF2B5EF4-FFF2-40B4-BE49-F238E27FC236}">
-                <a16:creationId xmlns:a16="http://schemas.microsoft.com/office/drawing/2014/main" id="{67ABA0BB-9C20-21AD-8A3C-7466BB98FFB8}"/>
-              </a:ext>
-            </a:extLst>
-          </p:cNvPr>
-          <p:cNvSpPr txBox="1">
-            <a:spLocks noGrp="1"/>
-          </p:cNvSpPr>
-          <p:nvPr>
-            <p:ph type="body" idx="1"/>
-          </p:nvPr>
-        </p:nvSpPr>
-        <p:spPr>
-          <a:xfrm>
-            <a:off x="685800" y="4343400"/>
-            <a:ext cx="5486400" cy="4114800"/>
-          </a:xfrm>
-          <a:prstGeom prst="rect">
-            <a:avLst/>
-          </a:prstGeom>
-          <a:noFill/>
-          <a:ln>
-            <a:noFill/>
-          </a:ln>
-        </p:spPr>
-        <p:txBody>
-          <a:bodyPr spcFirstLastPara="1" wrap="square" lIns="91425" tIns="91425" rIns="91425" bIns="91425" anchor="t" anchorCtr="0">
-            <a:noAutofit/>
-          </a:bodyPr>
-          <a:lstStyle/>
-          <a:p>
-            <a:pPr marL="0" lvl="0" indent="0" algn="l" rtl="0">
-              <a:lnSpc>
-                <a:spcPct val="100000"/>
-              </a:lnSpc>
-              <a:spcBef>
-                <a:spcPts val="0"/>
-              </a:spcBef>
-              <a:spcAft>
-                <a:spcPts val="0"/>
-              </a:spcAft>
-              <a:buSzPts val="1100"/>
-              <a:buNone/>
-            </a:pPr>
-            <a:endParaRPr/>
-          </a:p>
-        </p:txBody>
-      </p:sp>
-    </p:spTree>
-    <p:extLst>
-      <p:ext uri="{BB962C8B-B14F-4D97-AF65-F5344CB8AC3E}">
-        <p14:creationId xmlns:p14="http://schemas.microsoft.com/office/powerpoint/2010/main" val="1261799647"/>
-      </p:ext>
-    </p:extLst>
-  </p:cSld>
-  <p:clrMapOvr>
-    <a:masterClrMapping/>
-  </p:clrMapOvr>
-</p:notes>
-</file>
-
-<file path=ppt/notesSlides/notesSlide6.xml><?xml version="1.0" encoding="utf-8"?>
-<p:notes xmlns:a="http://schemas.openxmlformats.org/drawingml/2006/main" xmlns:r="http://schemas.openxmlformats.org/officeDocument/2006/relationships" xmlns:p="http://schemas.openxmlformats.org/presentationml/2006/main" showMasterSp="0" showMasterPhAnim="0">
-  <p:cSld>
-    <p:spTree>
-      <p:nvGrpSpPr>
-        <p:cNvPr id="1" name="Shape 77">
-          <a:extLst>
-            <a:ext uri="{FF2B5EF4-FFF2-40B4-BE49-F238E27FC236}">
               <a16:creationId xmlns:a16="http://schemas.microsoft.com/office/drawing/2014/main" id="{57AFCA1D-53D3-9FAE-B9E2-FA8311EA2305}"/>
             </a:ext>
           </a:extLst>
@@ -2852,7 +2110,7 @@
 </p:notes>
 </file>
 
-<file path=ppt/notesSlides/notesSlide7.xml><?xml version="1.0" encoding="utf-8"?>
+<file path=ppt/notesSlides/notesSlide6.xml><?xml version="1.0" encoding="utf-8"?>
 <p:notes xmlns:a="http://schemas.openxmlformats.org/drawingml/2006/main" xmlns:r="http://schemas.openxmlformats.org/officeDocument/2006/relationships" xmlns:p="http://schemas.openxmlformats.org/presentationml/2006/main" showMasterSp="0" showMasterPhAnim="0">
   <p:cSld>
     <p:spTree>
@@ -2997,7 +2255,7 @@
 </p:notes>
 </file>
 
-<file path=ppt/notesSlides/notesSlide8.xml><?xml version="1.0" encoding="utf-8"?>
+<file path=ppt/notesSlides/notesSlide7.xml><?xml version="1.0" encoding="utf-8"?>
 <p:notes xmlns:a="http://schemas.openxmlformats.org/drawingml/2006/main" xmlns:r="http://schemas.openxmlformats.org/officeDocument/2006/relationships" xmlns:p="http://schemas.openxmlformats.org/presentationml/2006/main" showMasterSp="0" showMasterPhAnim="0">
   <p:cSld>
     <p:spTree>
@@ -3142,7 +2400,7 @@
 </p:notes>
 </file>
 
-<file path=ppt/notesSlides/notesSlide9.xml><?xml version="1.0" encoding="utf-8"?>
+<file path=ppt/notesSlides/notesSlide8.xml><?xml version="1.0" encoding="utf-8"?>
 <p:notes xmlns:a="http://schemas.openxmlformats.org/drawingml/2006/main" xmlns:r="http://schemas.openxmlformats.org/officeDocument/2006/relationships" xmlns:p="http://schemas.openxmlformats.org/presentationml/2006/main" showMasterSp="0" showMasterPhAnim="0">
   <p:cSld>
     <p:spTree>
@@ -3150,7 +2408,7 @@
         <p:cNvPr id="1" name="Shape 77">
           <a:extLst>
             <a:ext uri="{FF2B5EF4-FFF2-40B4-BE49-F238E27FC236}">
-              <a16:creationId xmlns:a16="http://schemas.microsoft.com/office/drawing/2014/main" id="{63AE2DAD-61E3-9D75-845C-E230ED784869}"/>
+              <a16:creationId xmlns:a16="http://schemas.microsoft.com/office/drawing/2014/main" id="{DE1F163D-9306-B63B-8A42-5A1B6E71D6FC}"/>
             </a:ext>
           </a:extLst>
         </p:cNvPr>
@@ -3170,7 +2428,7 @@
           <p:cNvPr id="78" name="Google Shape;78;gf4f11f959e_0_5:notes">
             <a:extLst>
               <a:ext uri="{FF2B5EF4-FFF2-40B4-BE49-F238E27FC236}">
-                <a16:creationId xmlns:a16="http://schemas.microsoft.com/office/drawing/2014/main" id="{ECD46BB2-B204-A5B5-50F9-3B7DEE8C04F4}"/>
+                <a16:creationId xmlns:a16="http://schemas.microsoft.com/office/drawing/2014/main" id="{A44DE11A-7589-D211-54C0-A40875A23DA1}"/>
               </a:ext>
             </a:extLst>
           </p:cNvPr>
@@ -3227,7 +2485,7 @@
           <p:cNvPr id="79" name="Google Shape;79;gf4f11f959e_0_5:notes">
             <a:extLst>
               <a:ext uri="{FF2B5EF4-FFF2-40B4-BE49-F238E27FC236}">
-                <a16:creationId xmlns:a16="http://schemas.microsoft.com/office/drawing/2014/main" id="{624A2996-7478-BDEB-1023-270295A2CF28}"/>
+                <a16:creationId xmlns:a16="http://schemas.microsoft.com/office/drawing/2014/main" id="{D530E629-5E77-0266-BA72-704E4E7606B0}"/>
               </a:ext>
             </a:extLst>
           </p:cNvPr>
@@ -3270,6 +2528,310 @@
               <a:buSzPts val="1100"/>
               <a:buNone/>
             </a:pPr>
+            <a:r>
+              <a:rPr lang="fr-FR" sz="1100" b="1" dirty="0" err="1"/>
+              <a:t>SimpleSpamDetector</a:t>
+            </a:r>
+            <a:r>
+              <a:rPr lang="fr-FR" sz="1100" b="1" dirty="0"/>
+              <a:t>: </a:t>
+            </a:r>
+            <a:r>
+              <a:rPr lang="fr-FR" sz="1100" dirty="0" err="1"/>
+              <a:t>Purpose</a:t>
+            </a:r>
+            <a:r>
+              <a:rPr lang="fr-FR" sz="1100" dirty="0"/>
+              <a:t>: A </a:t>
+            </a:r>
+            <a:r>
+              <a:rPr lang="fr-FR" sz="1100" dirty="0" err="1"/>
+              <a:t>foundational</a:t>
+            </a:r>
+            <a:r>
+              <a:rPr lang="fr-FR" sz="1100" dirty="0"/>
+              <a:t> model to </a:t>
+            </a:r>
+            <a:r>
+              <a:rPr lang="fr-FR" sz="1100" dirty="0" err="1"/>
+              <a:t>leverage</a:t>
+            </a:r>
+            <a:r>
+              <a:rPr lang="fr-FR" sz="1100" dirty="0"/>
+              <a:t> the </a:t>
+            </a:r>
+            <a:r>
+              <a:rPr lang="fr-FR" sz="1100" dirty="0" err="1"/>
+              <a:t>combined</a:t>
+            </a:r>
+            <a:r>
+              <a:rPr lang="fr-FR" sz="1100" dirty="0"/>
+              <a:t> </a:t>
+            </a:r>
+            <a:r>
+              <a:rPr lang="fr-FR" sz="1100" dirty="0" err="1"/>
+              <a:t>semantic</a:t>
+            </a:r>
+            <a:r>
+              <a:rPr lang="fr-FR" sz="1100" dirty="0"/>
+              <a:t> </a:t>
+            </a:r>
+            <a:r>
+              <a:rPr lang="fr-FR" sz="1100" dirty="0" err="1"/>
+              <a:t>embeddings</a:t>
+            </a:r>
+            <a:r>
+              <a:rPr lang="fr-FR" sz="1100" dirty="0"/>
+              <a:t> and </a:t>
+            </a:r>
+            <a:r>
+              <a:rPr lang="fr-FR" sz="1100" dirty="0" err="1"/>
+              <a:t>engineered</a:t>
+            </a:r>
+            <a:r>
+              <a:rPr lang="fr-FR" sz="1100" dirty="0"/>
+              <a:t> </a:t>
+            </a:r>
+            <a:r>
+              <a:rPr lang="fr-FR" sz="1100" dirty="0" err="1"/>
+              <a:t>features</a:t>
+            </a:r>
+            <a:r>
+              <a:rPr lang="fr-FR" sz="1100" dirty="0"/>
+              <a:t>.</a:t>
+            </a:r>
+          </a:p>
+          <a:p>
+            <a:pPr marL="0" lvl="0" indent="0" algn="l" rtl="0">
+              <a:lnSpc>
+                <a:spcPct val="100000"/>
+              </a:lnSpc>
+              <a:spcBef>
+                <a:spcPts val="0"/>
+              </a:spcBef>
+              <a:spcAft>
+                <a:spcPts val="0"/>
+              </a:spcAft>
+              <a:buSzPts val="1100"/>
+              <a:buNone/>
+            </a:pPr>
+            <a:endParaRPr lang="fr-FR" sz="1100" dirty="0"/>
+          </a:p>
+          <a:p>
+            <a:pPr marL="0" lvl="0" indent="0" algn="l" rtl="0">
+              <a:lnSpc>
+                <a:spcPct val="100000"/>
+              </a:lnSpc>
+              <a:spcBef>
+                <a:spcPts val="0"/>
+              </a:spcBef>
+              <a:spcAft>
+                <a:spcPts val="0"/>
+              </a:spcAft>
+              <a:buSzPts val="1100"/>
+              <a:buNone/>
+            </a:pPr>
+            <a:r>
+              <a:rPr lang="fr-FR" sz="1100" b="1" dirty="0" err="1"/>
+              <a:t>UltraSimpleSpamDetector</a:t>
+            </a:r>
+            <a:r>
+              <a:rPr lang="fr-FR" sz="1100" b="1" dirty="0"/>
+              <a:t>: </a:t>
+            </a:r>
+            <a:r>
+              <a:rPr lang="fr-FR" sz="1100" dirty="0" err="1"/>
+              <a:t>Purpose</a:t>
+            </a:r>
+            <a:r>
+              <a:rPr lang="fr-FR" sz="1100" dirty="0"/>
+              <a:t>: A </a:t>
+            </a:r>
+            <a:r>
+              <a:rPr lang="fr-FR" sz="1100" dirty="0" err="1"/>
+              <a:t>highly</a:t>
+            </a:r>
+            <a:r>
+              <a:rPr lang="fr-FR" sz="1100" dirty="0"/>
+              <a:t> efficient, minimal model </a:t>
+            </a:r>
+            <a:r>
+              <a:rPr lang="fr-FR" sz="1100" dirty="0" err="1"/>
+              <a:t>designed</a:t>
+            </a:r>
+            <a:r>
+              <a:rPr lang="fr-FR" sz="1100" dirty="0"/>
+              <a:t> for </a:t>
+            </a:r>
+            <a:r>
+              <a:rPr lang="fr-FR" sz="1100" dirty="0" err="1"/>
+              <a:t>faster</a:t>
+            </a:r>
+            <a:r>
+              <a:rPr lang="fr-FR" sz="1100" dirty="0"/>
+              <a:t> training and </a:t>
+            </a:r>
+            <a:r>
+              <a:rPr lang="fr-FR" sz="1100" dirty="0" err="1"/>
+              <a:t>deployment</a:t>
+            </a:r>
+            <a:r>
+              <a:rPr lang="fr-FR" sz="1100" dirty="0"/>
+              <a:t> </a:t>
+            </a:r>
+            <a:r>
+              <a:rPr lang="fr-FR" sz="1100" dirty="0" err="1"/>
+              <a:t>with</a:t>
+            </a:r>
+            <a:r>
+              <a:rPr lang="fr-FR" sz="1100" dirty="0"/>
+              <a:t> comparable performance.</a:t>
+            </a:r>
+            <a:endParaRPr dirty="0"/>
+          </a:p>
+        </p:txBody>
+      </p:sp>
+    </p:spTree>
+    <p:extLst>
+      <p:ext uri="{BB962C8B-B14F-4D97-AF65-F5344CB8AC3E}">
+        <p14:creationId xmlns:p14="http://schemas.microsoft.com/office/powerpoint/2010/main" val="353194640"/>
+      </p:ext>
+    </p:extLst>
+  </p:cSld>
+  <p:clrMapOvr>
+    <a:masterClrMapping/>
+  </p:clrMapOvr>
+</p:notes>
+</file>
+
+<file path=ppt/notesSlides/notesSlide9.xml><?xml version="1.0" encoding="utf-8"?>
+<p:notes xmlns:a="http://schemas.openxmlformats.org/drawingml/2006/main" xmlns:r="http://schemas.openxmlformats.org/officeDocument/2006/relationships" xmlns:p="http://schemas.openxmlformats.org/presentationml/2006/main" showMasterSp="0" showMasterPhAnim="0">
+  <p:cSld>
+    <p:spTree>
+      <p:nvGrpSpPr>
+        <p:cNvPr id="1" name="Shape 77">
+          <a:extLst>
+            <a:ext uri="{FF2B5EF4-FFF2-40B4-BE49-F238E27FC236}">
+              <a16:creationId xmlns:a16="http://schemas.microsoft.com/office/drawing/2014/main" id="{E66714CB-0328-AADF-7A6C-F2EED746642A}"/>
+            </a:ext>
+          </a:extLst>
+        </p:cNvPr>
+        <p:cNvGrpSpPr/>
+        <p:nvPr/>
+      </p:nvGrpSpPr>
+      <p:grpSpPr>
+        <a:xfrm>
+          <a:off x="0" y="0"/>
+          <a:ext cx="0" cy="0"/>
+          <a:chOff x="0" y="0"/>
+          <a:chExt cx="0" cy="0"/>
+        </a:xfrm>
+      </p:grpSpPr>
+      <p:sp>
+        <p:nvSpPr>
+          <p:cNvPr id="78" name="Google Shape;78;gf4f11f959e_0_5:notes">
+            <a:extLst>
+              <a:ext uri="{FF2B5EF4-FFF2-40B4-BE49-F238E27FC236}">
+                <a16:creationId xmlns:a16="http://schemas.microsoft.com/office/drawing/2014/main" id="{4409C3C1-FA78-E144-2871-CB6AF5B64587}"/>
+              </a:ext>
+            </a:extLst>
+          </p:cNvPr>
+          <p:cNvSpPr>
+            <a:spLocks noGrp="1" noRot="1" noChangeAspect="1"/>
+          </p:cNvSpPr>
+          <p:nvPr>
+            <p:ph type="sldImg" idx="2"/>
+          </p:nvPr>
+        </p:nvSpPr>
+        <p:spPr>
+          <a:xfrm>
+            <a:off x="381000" y="685800"/>
+            <a:ext cx="6096000" cy="3429000"/>
+          </a:xfrm>
+          <a:custGeom>
+            <a:avLst/>
+            <a:gdLst/>
+            <a:ahLst/>
+            <a:cxnLst/>
+            <a:rect l="l" t="t" r="r" b="b"/>
+            <a:pathLst>
+              <a:path w="120000" h="120000" extrusionOk="0">
+                <a:moveTo>
+                  <a:pt x="0" y="0"/>
+                </a:moveTo>
+                <a:lnTo>
+                  <a:pt x="120000" y="0"/>
+                </a:lnTo>
+                <a:lnTo>
+                  <a:pt x="120000" y="120000"/>
+                </a:lnTo>
+                <a:lnTo>
+                  <a:pt x="0" y="120000"/>
+                </a:lnTo>
+                <a:close/>
+              </a:path>
+            </a:pathLst>
+          </a:custGeom>
+          <a:noFill/>
+          <a:ln w="9525" cap="flat" cmpd="sng">
+            <a:solidFill>
+              <a:srgbClr val="000000"/>
+            </a:solidFill>
+            <a:prstDash val="solid"/>
+            <a:round/>
+            <a:headEnd type="none" w="sm" len="sm"/>
+            <a:tailEnd type="none" w="sm" len="sm"/>
+          </a:ln>
+        </p:spPr>
+      </p:sp>
+      <p:sp>
+        <p:nvSpPr>
+          <p:cNvPr id="79" name="Google Shape;79;gf4f11f959e_0_5:notes">
+            <a:extLst>
+              <a:ext uri="{FF2B5EF4-FFF2-40B4-BE49-F238E27FC236}">
+                <a16:creationId xmlns:a16="http://schemas.microsoft.com/office/drawing/2014/main" id="{2292C057-74F5-AC0B-F0A1-A7CE21EEA999}"/>
+              </a:ext>
+            </a:extLst>
+          </p:cNvPr>
+          <p:cNvSpPr txBox="1">
+            <a:spLocks noGrp="1"/>
+          </p:cNvSpPr>
+          <p:nvPr>
+            <p:ph type="body" idx="1"/>
+          </p:nvPr>
+        </p:nvSpPr>
+        <p:spPr>
+          <a:xfrm>
+            <a:off x="685800" y="4343400"/>
+            <a:ext cx="5486400" cy="4114800"/>
+          </a:xfrm>
+          <a:prstGeom prst="rect">
+            <a:avLst/>
+          </a:prstGeom>
+          <a:noFill/>
+          <a:ln>
+            <a:noFill/>
+          </a:ln>
+        </p:spPr>
+        <p:txBody>
+          <a:bodyPr spcFirstLastPara="1" wrap="square" lIns="91425" tIns="91425" rIns="91425" bIns="91425" anchor="t" anchorCtr="0">
+            <a:noAutofit/>
+          </a:bodyPr>
+          <a:lstStyle/>
+          <a:p>
+            <a:pPr marL="0" lvl="0" indent="0" algn="l" rtl="0">
+              <a:lnSpc>
+                <a:spcPct val="100000"/>
+              </a:lnSpc>
+              <a:spcBef>
+                <a:spcPts val="0"/>
+              </a:spcBef>
+              <a:spcAft>
+                <a:spcPts val="0"/>
+              </a:spcAft>
+              <a:buSzPts val="1100"/>
+              <a:buNone/>
+            </a:pPr>
             <a:endParaRPr/>
           </a:p>
         </p:txBody>
@@ -3277,7 +2839,7 @@
     </p:spTree>
     <p:extLst>
       <p:ext uri="{BB962C8B-B14F-4D97-AF65-F5344CB8AC3E}">
-        <p14:creationId xmlns:p14="http://schemas.microsoft.com/office/powerpoint/2010/main" val="384385576"/>
+        <p14:creationId xmlns:p14="http://schemas.microsoft.com/office/powerpoint/2010/main" val="3052372965"/>
       </p:ext>
     </p:extLst>
   </p:cSld>
@@ -8532,1195 +8094,6 @@
         <p:cNvPr id="1" name="Shape 80">
           <a:extLst>
             <a:ext uri="{FF2B5EF4-FFF2-40B4-BE49-F238E27FC236}">
-              <a16:creationId xmlns:a16="http://schemas.microsoft.com/office/drawing/2014/main" id="{D9DE7D89-C1F7-A4A3-4CED-1BDCD203B867}"/>
-            </a:ext>
-          </a:extLst>
-        </p:cNvPr>
-        <p:cNvGrpSpPr/>
-        <p:nvPr/>
-      </p:nvGrpSpPr>
-      <p:grpSpPr>
-        <a:xfrm>
-          <a:off x="0" y="0"/>
-          <a:ext cx="0" cy="0"/>
-          <a:chOff x="0" y="0"/>
-          <a:chExt cx="0" cy="0"/>
-        </a:xfrm>
-      </p:grpSpPr>
-      <p:sp>
-        <p:nvSpPr>
-          <p:cNvPr id="81" name="Google Shape;81;p16">
-            <a:extLst>
-              <a:ext uri="{FF2B5EF4-FFF2-40B4-BE49-F238E27FC236}">
-                <a16:creationId xmlns:a16="http://schemas.microsoft.com/office/drawing/2014/main" id="{C8806206-5BF8-B5CB-7F02-C901346802F4}"/>
-              </a:ext>
-            </a:extLst>
-          </p:cNvPr>
-          <p:cNvSpPr/>
-          <p:nvPr/>
-        </p:nvSpPr>
-        <p:spPr>
-          <a:xfrm>
-            <a:off x="5499" y="-17775"/>
-            <a:ext cx="3520625" cy="5161200"/>
-          </a:xfrm>
-          <a:prstGeom prst="rect">
-            <a:avLst/>
-          </a:prstGeom>
-          <a:solidFill>
-            <a:srgbClr val="C3FFFC"/>
-          </a:solidFill>
-          <a:ln>
-            <a:noFill/>
-          </a:ln>
-        </p:spPr>
-        <p:txBody>
-          <a:bodyPr spcFirstLastPara="1" wrap="square" lIns="91425" tIns="91425" rIns="91425" bIns="91425" anchor="ctr" anchorCtr="0">
-            <a:noAutofit/>
-          </a:bodyPr>
-          <a:lstStyle/>
-          <a:p>
-            <a:pPr marL="0" marR="0" lvl="0" indent="0" algn="l" rtl="0">
-              <a:lnSpc>
-                <a:spcPct val="100000"/>
-              </a:lnSpc>
-              <a:spcBef>
-                <a:spcPts val="0"/>
-              </a:spcBef>
-              <a:spcAft>
-                <a:spcPts val="0"/>
-              </a:spcAft>
-              <a:buClr>
-                <a:srgbClr val="000000"/>
-              </a:buClr>
-              <a:buSzPts val="1400"/>
-              <a:buFont typeface="Arial"/>
-              <a:buNone/>
-            </a:pPr>
-            <a:endParaRPr sz="1400" b="0" i="0" u="none" strike="noStrike" cap="none">
-              <a:solidFill>
-                <a:srgbClr val="000000"/>
-              </a:solidFill>
-              <a:latin typeface="Arial"/>
-              <a:ea typeface="Arial"/>
-              <a:cs typeface="Arial"/>
-              <a:sym typeface="Arial"/>
-            </a:endParaRPr>
-          </a:p>
-        </p:txBody>
-      </p:sp>
-      <p:sp>
-        <p:nvSpPr>
-          <p:cNvPr id="82" name="Google Shape;82;p16">
-            <a:extLst>
-              <a:ext uri="{FF2B5EF4-FFF2-40B4-BE49-F238E27FC236}">
-                <a16:creationId xmlns:a16="http://schemas.microsoft.com/office/drawing/2014/main" id="{A76B9C11-15D3-4C6F-276A-F0FAA446B3B5}"/>
-              </a:ext>
-            </a:extLst>
-          </p:cNvPr>
-          <p:cNvSpPr txBox="1">
-            <a:spLocks noGrp="1"/>
-          </p:cNvSpPr>
-          <p:nvPr>
-            <p:ph type="title"/>
-          </p:nvPr>
-        </p:nvSpPr>
-        <p:spPr>
-          <a:xfrm>
-            <a:off x="438808" y="967077"/>
-            <a:ext cx="2988031" cy="3774288"/>
-          </a:xfrm>
-          <a:prstGeom prst="rect">
-            <a:avLst/>
-          </a:prstGeom>
-          <a:noFill/>
-          <a:ln>
-            <a:noFill/>
-          </a:ln>
-        </p:spPr>
-        <p:txBody>
-          <a:bodyPr spcFirstLastPara="1" wrap="square" lIns="91425" tIns="91425" rIns="91425" bIns="91425" anchor="t" anchorCtr="0">
-            <a:noAutofit/>
-          </a:bodyPr>
-          <a:lstStyle/>
-          <a:p>
-            <a:r>
-              <a:rPr lang="fr-FR" b="1" noProof="0" dirty="0"/>
-              <a:t>Architecture des modèles neuronaux </a:t>
-            </a:r>
-            <a:br>
-              <a:rPr lang="fr-FR" b="1" noProof="0" dirty="0"/>
-            </a:br>
-            <a:br>
-              <a:rPr lang="fr-FR" noProof="0" dirty="0"/>
-            </a:br>
-            <a:r>
-              <a:rPr lang="fr-FR" sz="2000" noProof="0" dirty="0"/>
-              <a:t>- 2 réseaux neuronaux à propagation directe pour une classification binaire efficace</a:t>
-            </a:r>
-            <a:br>
-              <a:rPr lang="fr-FR" b="1" noProof="0" dirty="0"/>
-            </a:br>
-            <a:br>
-              <a:rPr lang="fr-FR" sz="2400" noProof="0" dirty="0">
-                <a:solidFill>
-                  <a:srgbClr val="015955"/>
-                </a:solidFill>
-                <a:latin typeface="Inter"/>
-                <a:ea typeface="Inter"/>
-                <a:cs typeface="Inter"/>
-                <a:sym typeface="Inter"/>
-              </a:rPr>
-            </a:br>
-            <a:br>
-              <a:rPr lang="fr-FR" sz="2400" noProof="0" dirty="0">
-                <a:solidFill>
-                  <a:srgbClr val="015955"/>
-                </a:solidFill>
-                <a:latin typeface="Inter"/>
-                <a:ea typeface="Inter"/>
-                <a:cs typeface="Inter"/>
-                <a:sym typeface="Inter"/>
-              </a:rPr>
-            </a:br>
-            <a:endParaRPr lang="fr-FR" sz="2400" noProof="0" dirty="0">
-              <a:solidFill>
-                <a:srgbClr val="015955"/>
-              </a:solidFill>
-              <a:latin typeface="Inter"/>
-              <a:ea typeface="Inter"/>
-              <a:cs typeface="Inter"/>
-              <a:sym typeface="Inter"/>
-            </a:endParaRPr>
-          </a:p>
-        </p:txBody>
-      </p:sp>
-      <p:pic>
-        <p:nvPicPr>
-          <p:cNvPr id="83" name="Google Shape;83;p16">
-            <a:extLst>
-              <a:ext uri="{FF2B5EF4-FFF2-40B4-BE49-F238E27FC236}">
-                <a16:creationId xmlns:a16="http://schemas.microsoft.com/office/drawing/2014/main" id="{1672457B-229E-7F7A-C9FF-AD2C3D6ABAA0}"/>
-              </a:ext>
-            </a:extLst>
-          </p:cNvPr>
-          <p:cNvPicPr preferRelativeResize="0"/>
-          <p:nvPr/>
-        </p:nvPicPr>
-        <p:blipFill rotWithShape="1">
-          <a:blip r:embed="rId3">
-            <a:alphaModFix/>
-          </a:blip>
-          <a:srcRect/>
-          <a:stretch/>
-        </p:blipFill>
-        <p:spPr>
-          <a:xfrm>
-            <a:off x="463375" y="482852"/>
-            <a:ext cx="576900" cy="385904"/>
-          </a:xfrm>
-          <a:prstGeom prst="rect">
-            <a:avLst/>
-          </a:prstGeom>
-          <a:noFill/>
-          <a:ln>
-            <a:noFill/>
-          </a:ln>
-        </p:spPr>
-      </p:pic>
-      <p:sp>
-        <p:nvSpPr>
-          <p:cNvPr id="84" name="Google Shape;84;p16">
-            <a:extLst>
-              <a:ext uri="{FF2B5EF4-FFF2-40B4-BE49-F238E27FC236}">
-                <a16:creationId xmlns:a16="http://schemas.microsoft.com/office/drawing/2014/main" id="{2BE524D9-0AA5-9467-7381-4ECE57E3DE0D}"/>
-              </a:ext>
-            </a:extLst>
-          </p:cNvPr>
-          <p:cNvSpPr txBox="1">
-            <a:spLocks noGrp="1"/>
-          </p:cNvSpPr>
-          <p:nvPr>
-            <p:ph type="ctrTitle" idx="4294967295"/>
-          </p:nvPr>
-        </p:nvSpPr>
-        <p:spPr>
-          <a:xfrm>
-            <a:off x="3588119" y="579248"/>
-            <a:ext cx="5315100" cy="4380457"/>
-          </a:xfrm>
-          <a:prstGeom prst="rect">
-            <a:avLst/>
-          </a:prstGeom>
-          <a:noFill/>
-          <a:ln>
-            <a:noFill/>
-          </a:ln>
-        </p:spPr>
-        <p:txBody>
-          <a:bodyPr spcFirstLastPara="1" wrap="square" lIns="91425" tIns="91425" rIns="91425" bIns="91425" anchor="t" anchorCtr="0">
-            <a:noAutofit/>
-          </a:bodyPr>
-          <a:lstStyle/>
-          <a:p>
-            <a:r>
-              <a:rPr lang="fr-FR" sz="1400" b="1" noProof="0" dirty="0" err="1"/>
-              <a:t>SimpleSpamDetector</a:t>
-            </a:r>
-            <a:r>
-              <a:rPr lang="fr-FR" sz="1400" b="1" noProof="0" dirty="0"/>
-              <a:t>:</a:t>
-            </a:r>
-            <a:br>
-              <a:rPr lang="fr-FR" sz="1400" noProof="0" dirty="0"/>
-            </a:br>
-            <a:br>
-              <a:rPr lang="fr-FR" sz="1400" noProof="0" dirty="0"/>
-            </a:br>
-            <a:r>
-              <a:rPr lang="fr-FR" sz="1400" noProof="0" dirty="0"/>
-              <a:t>Architecture: Couche d’entrée </a:t>
-            </a:r>
-            <a:r>
-              <a:rPr lang="fr-FR" sz="1400" b="1" noProof="0" dirty="0"/>
-              <a:t>(392 variables</a:t>
-            </a:r>
-            <a:r>
-              <a:rPr lang="fr-FR" sz="1400" noProof="0" dirty="0"/>
-              <a:t>) → Couche cachée (</a:t>
-            </a:r>
-            <a:r>
-              <a:rPr lang="fr-FR" sz="1400" b="1" noProof="0" dirty="0"/>
-              <a:t>128 neurones</a:t>
-            </a:r>
-            <a:r>
-              <a:rPr lang="fr-FR" sz="1400" noProof="0" dirty="0"/>
-              <a:t>, activation </a:t>
-            </a:r>
-            <a:r>
-              <a:rPr lang="fr-FR" sz="1400" noProof="0" dirty="0" err="1"/>
-              <a:t>ReLU</a:t>
-            </a:r>
-            <a:r>
-              <a:rPr lang="fr-FR" sz="1400" noProof="0" dirty="0"/>
-              <a:t>, Dropout) → Couche de sortie (</a:t>
-            </a:r>
-            <a:r>
-              <a:rPr lang="fr-FR" sz="1400" b="1" noProof="0" dirty="0"/>
-              <a:t>1 neurone</a:t>
-            </a:r>
-            <a:r>
-              <a:rPr lang="fr-FR" sz="1400" noProof="0" dirty="0"/>
-              <a:t>, activation </a:t>
-            </a:r>
-            <a:r>
-              <a:rPr lang="fr-FR" sz="1400" noProof="0" dirty="0" err="1"/>
-              <a:t>Sigmoid</a:t>
-            </a:r>
-            <a:r>
-              <a:rPr lang="fr-FR" sz="1400" noProof="0" dirty="0"/>
-              <a:t> pour la probabilité).</a:t>
-            </a:r>
-            <a:br>
-              <a:rPr lang="fr-FR" sz="1400" noProof="0" dirty="0"/>
-            </a:br>
-            <a:br>
-              <a:rPr lang="fr-FR" sz="1400" noProof="0" dirty="0"/>
-            </a:br>
-            <a:r>
-              <a:rPr lang="fr-FR" sz="1400" b="1" noProof="0" dirty="0"/>
-              <a:t>Paramètres: environ 50,433.</a:t>
-            </a:r>
-            <a:br>
-              <a:rPr lang="fr-FR" sz="1400" noProof="0" dirty="0"/>
-            </a:br>
-            <a:br>
-              <a:rPr lang="fr-FR" sz="1400" noProof="0" dirty="0"/>
-            </a:br>
-            <a:br>
-              <a:rPr lang="fr-FR" sz="1400" noProof="0" dirty="0"/>
-            </a:br>
-            <a:r>
-              <a:rPr lang="fr-FR" sz="1400" b="1" noProof="0" dirty="0" err="1"/>
-              <a:t>UltraSimpleSpamDetector</a:t>
-            </a:r>
-            <a:r>
-              <a:rPr lang="fr-FR" sz="1400" b="1" noProof="0" dirty="0"/>
-              <a:t>:</a:t>
-            </a:r>
-            <a:br>
-              <a:rPr lang="fr-FR" sz="1400" noProof="0" dirty="0"/>
-            </a:br>
-            <a:br>
-              <a:rPr lang="fr-FR" sz="1400" noProof="0" dirty="0"/>
-            </a:br>
-            <a:r>
-              <a:rPr lang="fr-FR" sz="1400" noProof="0" dirty="0"/>
-              <a:t>Architecture: Couche d’entrée (</a:t>
-            </a:r>
-            <a:r>
-              <a:rPr lang="fr-FR" sz="1400" b="1" noProof="0" dirty="0"/>
-              <a:t>392 variables</a:t>
-            </a:r>
-            <a:r>
-              <a:rPr lang="fr-FR" sz="1400" noProof="0" dirty="0"/>
-              <a:t>) → Couche cachée (</a:t>
-            </a:r>
-            <a:r>
-              <a:rPr lang="fr-FR" sz="1400" b="1" noProof="0" dirty="0"/>
-              <a:t>64 neurones</a:t>
-            </a:r>
-            <a:r>
-              <a:rPr lang="fr-FR" sz="1400" noProof="0" dirty="0"/>
-              <a:t>, activation </a:t>
-            </a:r>
-            <a:r>
-              <a:rPr lang="fr-FR" sz="1400" noProof="0" dirty="0" err="1"/>
-              <a:t>ReLU</a:t>
-            </a:r>
-            <a:r>
-              <a:rPr lang="fr-FR" sz="1400" noProof="0" dirty="0"/>
-              <a:t>, Dropout) → Couche de sortie (</a:t>
-            </a:r>
-            <a:r>
-              <a:rPr lang="fr-FR" sz="1400" b="1" noProof="0" dirty="0"/>
-              <a:t>1 neurone</a:t>
-            </a:r>
-            <a:r>
-              <a:rPr lang="fr-FR" sz="1400" noProof="0" dirty="0"/>
-              <a:t>, activation </a:t>
-            </a:r>
-            <a:r>
-              <a:rPr lang="fr-FR" sz="1400" noProof="0" dirty="0" err="1"/>
-              <a:t>Sigmoid</a:t>
-            </a:r>
-            <a:r>
-              <a:rPr lang="fr-FR" sz="1400" noProof="0" dirty="0"/>
-              <a:t> pour la probabilité).</a:t>
-            </a:r>
-            <a:br>
-              <a:rPr lang="fr-FR" sz="1400" noProof="0" dirty="0"/>
-            </a:br>
-            <a:br>
-              <a:rPr lang="fr-FR" sz="1400" noProof="0" dirty="0"/>
-            </a:br>
-            <a:r>
-              <a:rPr lang="fr-FR" sz="1400" b="1" noProof="0" dirty="0"/>
-              <a:t>Paramètres: environ 25,217.</a:t>
-            </a:r>
-            <a:br>
-              <a:rPr lang="fr-FR" sz="1400" noProof="0" dirty="0"/>
-            </a:br>
-            <a:br>
-              <a:rPr lang="fr-FR" sz="1400" noProof="0" dirty="0"/>
-            </a:br>
-            <a:br>
-              <a:rPr lang="fr-FR" noProof="0" dirty="0"/>
-            </a:br>
-            <a:br>
-              <a:rPr lang="fr-FR" sz="1600" noProof="0" dirty="0"/>
-            </a:br>
-            <a:br>
-              <a:rPr lang="fr-FR" noProof="0" dirty="0"/>
-            </a:br>
-            <a:br>
-              <a:rPr lang="fr-FR" sz="1600" noProof="0" dirty="0"/>
-            </a:br>
-            <a:br>
-              <a:rPr lang="fr-FR" noProof="0" dirty="0"/>
-            </a:br>
-            <a:endParaRPr lang="fr-FR" sz="1600" noProof="0" dirty="0"/>
-          </a:p>
-        </p:txBody>
-      </p:sp>
-    </p:spTree>
-    <p:extLst>
-      <p:ext uri="{BB962C8B-B14F-4D97-AF65-F5344CB8AC3E}">
-        <p14:creationId xmlns:p14="http://schemas.microsoft.com/office/powerpoint/2010/main" val="851915911"/>
-      </p:ext>
-    </p:extLst>
-  </p:cSld>
-  <p:clrMapOvr>
-    <a:masterClrMapping/>
-  </p:clrMapOvr>
-</p:sld>
-</file>
-
-<file path=ppt/slides/slide11.xml><?xml version="1.0" encoding="utf-8"?>
-<p:sld xmlns:a="http://schemas.openxmlformats.org/drawingml/2006/main" xmlns:r="http://schemas.openxmlformats.org/officeDocument/2006/relationships" xmlns:p="http://schemas.openxmlformats.org/presentationml/2006/main" show="0">
-  <p:cSld>
-    <p:spTree>
-      <p:nvGrpSpPr>
-        <p:cNvPr id="1" name="Shape 80">
-          <a:extLst>
-            <a:ext uri="{FF2B5EF4-FFF2-40B4-BE49-F238E27FC236}">
-              <a16:creationId xmlns:a16="http://schemas.microsoft.com/office/drawing/2014/main" id="{520ADF24-A96D-5542-D7AA-9FAB09665FE6}"/>
-            </a:ext>
-          </a:extLst>
-        </p:cNvPr>
-        <p:cNvGrpSpPr/>
-        <p:nvPr/>
-      </p:nvGrpSpPr>
-      <p:grpSpPr>
-        <a:xfrm>
-          <a:off x="0" y="0"/>
-          <a:ext cx="0" cy="0"/>
-          <a:chOff x="0" y="0"/>
-          <a:chExt cx="0" cy="0"/>
-        </a:xfrm>
-      </p:grpSpPr>
-      <p:sp>
-        <p:nvSpPr>
-          <p:cNvPr id="81" name="Google Shape;81;p16">
-            <a:extLst>
-              <a:ext uri="{FF2B5EF4-FFF2-40B4-BE49-F238E27FC236}">
-                <a16:creationId xmlns:a16="http://schemas.microsoft.com/office/drawing/2014/main" id="{6C15E693-D567-8947-2500-19E39B53C9EF}"/>
-              </a:ext>
-            </a:extLst>
-          </p:cNvPr>
-          <p:cNvSpPr/>
-          <p:nvPr/>
-        </p:nvSpPr>
-        <p:spPr>
-          <a:xfrm>
-            <a:off x="5499" y="-17775"/>
-            <a:ext cx="3520625" cy="5161200"/>
-          </a:xfrm>
-          <a:prstGeom prst="rect">
-            <a:avLst/>
-          </a:prstGeom>
-          <a:solidFill>
-            <a:srgbClr val="C3FFFC"/>
-          </a:solidFill>
-          <a:ln>
-            <a:noFill/>
-          </a:ln>
-        </p:spPr>
-        <p:txBody>
-          <a:bodyPr spcFirstLastPara="1" wrap="square" lIns="91425" tIns="91425" rIns="91425" bIns="91425" anchor="ctr" anchorCtr="0">
-            <a:noAutofit/>
-          </a:bodyPr>
-          <a:lstStyle/>
-          <a:p>
-            <a:pPr marL="0" marR="0" lvl="0" indent="0" algn="l" rtl="0">
-              <a:lnSpc>
-                <a:spcPct val="100000"/>
-              </a:lnSpc>
-              <a:spcBef>
-                <a:spcPts val="0"/>
-              </a:spcBef>
-              <a:spcAft>
-                <a:spcPts val="0"/>
-              </a:spcAft>
-              <a:buClr>
-                <a:srgbClr val="000000"/>
-              </a:buClr>
-              <a:buSzPts val="1400"/>
-              <a:buFont typeface="Arial"/>
-              <a:buNone/>
-            </a:pPr>
-            <a:endParaRPr sz="1400" b="0" i="0" u="none" strike="noStrike" cap="none">
-              <a:solidFill>
-                <a:srgbClr val="000000"/>
-              </a:solidFill>
-              <a:latin typeface="Arial"/>
-              <a:ea typeface="Arial"/>
-              <a:cs typeface="Arial"/>
-              <a:sym typeface="Arial"/>
-            </a:endParaRPr>
-          </a:p>
-        </p:txBody>
-      </p:sp>
-      <p:sp>
-        <p:nvSpPr>
-          <p:cNvPr id="82" name="Google Shape;82;p16">
-            <a:extLst>
-              <a:ext uri="{FF2B5EF4-FFF2-40B4-BE49-F238E27FC236}">
-                <a16:creationId xmlns:a16="http://schemas.microsoft.com/office/drawing/2014/main" id="{5A8CD565-7FB9-F6BA-5DFF-426B16E9B1F1}"/>
-              </a:ext>
-            </a:extLst>
-          </p:cNvPr>
-          <p:cNvSpPr txBox="1">
-            <a:spLocks noGrp="1"/>
-          </p:cNvSpPr>
-          <p:nvPr>
-            <p:ph type="title"/>
-          </p:nvPr>
-        </p:nvSpPr>
-        <p:spPr>
-          <a:xfrm>
-            <a:off x="438808" y="967077"/>
-            <a:ext cx="2988031" cy="3774288"/>
-          </a:xfrm>
-          <a:prstGeom prst="rect">
-            <a:avLst/>
-          </a:prstGeom>
-          <a:noFill/>
-          <a:ln>
-            <a:noFill/>
-          </a:ln>
-        </p:spPr>
-        <p:txBody>
-          <a:bodyPr spcFirstLastPara="1" wrap="square" lIns="91425" tIns="91425" rIns="91425" bIns="91425" anchor="t" anchorCtr="0">
-            <a:noAutofit/>
-          </a:bodyPr>
-          <a:lstStyle/>
-          <a:p>
-            <a:r>
-              <a:rPr lang="en-US" b="1" dirty="0"/>
-              <a:t>Processus </a:t>
-            </a:r>
-            <a:r>
-              <a:rPr lang="en-US" b="1" dirty="0" err="1"/>
-              <a:t>d’entraînement</a:t>
-            </a:r>
-            <a:r>
-              <a:rPr lang="en-US" b="1" dirty="0"/>
-              <a:t> et ponderation des classes</a:t>
-            </a:r>
-            <a:br>
-              <a:rPr lang="en-US" dirty="0"/>
-            </a:br>
-            <a:br>
-              <a:rPr lang="fr-FR" dirty="0"/>
-            </a:br>
-            <a:br>
-              <a:rPr lang="en-US" dirty="0"/>
-            </a:br>
-            <a:r>
-              <a:rPr lang="en-US" sz="2000" dirty="0"/>
-              <a:t>- </a:t>
-            </a:r>
-            <a:r>
-              <a:rPr lang="fr-FR" dirty="0"/>
-              <a:t>Aspects clés de l’entraînement</a:t>
-            </a:r>
-            <a:br>
-              <a:rPr lang="fr-FR" dirty="0"/>
-            </a:br>
-            <a:br>
-              <a:rPr lang="fr-FR" b="1" dirty="0"/>
-            </a:br>
-            <a:br>
-              <a:rPr lang="fr" sz="2400" dirty="0">
-                <a:solidFill>
-                  <a:srgbClr val="015955"/>
-                </a:solidFill>
-                <a:latin typeface="Inter"/>
-                <a:ea typeface="Inter"/>
-                <a:cs typeface="Inter"/>
-                <a:sym typeface="Inter"/>
-              </a:rPr>
-            </a:br>
-            <a:br>
-              <a:rPr lang="fr" sz="2400" dirty="0">
-                <a:solidFill>
-                  <a:srgbClr val="015955"/>
-                </a:solidFill>
-                <a:latin typeface="Inter"/>
-                <a:ea typeface="Inter"/>
-                <a:cs typeface="Inter"/>
-                <a:sym typeface="Inter"/>
-              </a:rPr>
-            </a:br>
-            <a:endParaRPr sz="2400" dirty="0">
-              <a:solidFill>
-                <a:srgbClr val="015955"/>
-              </a:solidFill>
-              <a:latin typeface="Inter"/>
-              <a:ea typeface="Inter"/>
-              <a:cs typeface="Inter"/>
-              <a:sym typeface="Inter"/>
-            </a:endParaRPr>
-          </a:p>
-        </p:txBody>
-      </p:sp>
-      <p:pic>
-        <p:nvPicPr>
-          <p:cNvPr id="83" name="Google Shape;83;p16">
-            <a:extLst>
-              <a:ext uri="{FF2B5EF4-FFF2-40B4-BE49-F238E27FC236}">
-                <a16:creationId xmlns:a16="http://schemas.microsoft.com/office/drawing/2014/main" id="{18DA176D-56A9-4569-D271-7173AA3F0E30}"/>
-              </a:ext>
-            </a:extLst>
-          </p:cNvPr>
-          <p:cNvPicPr preferRelativeResize="0"/>
-          <p:nvPr/>
-        </p:nvPicPr>
-        <p:blipFill rotWithShape="1">
-          <a:blip r:embed="rId3">
-            <a:alphaModFix/>
-          </a:blip>
-          <a:srcRect/>
-          <a:stretch/>
-        </p:blipFill>
-        <p:spPr>
-          <a:xfrm>
-            <a:off x="463375" y="482852"/>
-            <a:ext cx="576900" cy="385904"/>
-          </a:xfrm>
-          <a:prstGeom prst="rect">
-            <a:avLst/>
-          </a:prstGeom>
-          <a:noFill/>
-          <a:ln>
-            <a:noFill/>
-          </a:ln>
-        </p:spPr>
-      </p:pic>
-      <p:sp>
-        <p:nvSpPr>
-          <p:cNvPr id="84" name="Google Shape;84;p16">
-            <a:extLst>
-              <a:ext uri="{FF2B5EF4-FFF2-40B4-BE49-F238E27FC236}">
-                <a16:creationId xmlns:a16="http://schemas.microsoft.com/office/drawing/2014/main" id="{F9D673B3-3E77-045F-8415-0441C81C90B2}"/>
-              </a:ext>
-            </a:extLst>
-          </p:cNvPr>
-          <p:cNvSpPr txBox="1">
-            <a:spLocks noGrp="1"/>
-          </p:cNvSpPr>
-          <p:nvPr>
-            <p:ph type="ctrTitle" idx="4294967295"/>
-          </p:nvPr>
-        </p:nvSpPr>
-        <p:spPr>
-          <a:xfrm>
-            <a:off x="3588119" y="579248"/>
-            <a:ext cx="5455142" cy="4488698"/>
-          </a:xfrm>
-          <a:prstGeom prst="rect">
-            <a:avLst/>
-          </a:prstGeom>
-          <a:noFill/>
-          <a:ln>
-            <a:noFill/>
-          </a:ln>
-        </p:spPr>
-        <p:txBody>
-          <a:bodyPr spcFirstLastPara="1" wrap="square" lIns="91425" tIns="91425" rIns="91425" bIns="91425" anchor="t" anchorCtr="0">
-            <a:noAutofit/>
-          </a:bodyPr>
-          <a:lstStyle/>
-          <a:p>
-            <a:r>
-              <a:rPr lang="en-US" sz="1400" b="1" dirty="0"/>
-              <a:t>Device Utilization: </a:t>
-            </a:r>
-            <a:r>
-              <a:rPr lang="en-US" sz="1400" dirty="0"/>
-              <a:t>use of </a:t>
-            </a:r>
-            <a:r>
-              <a:rPr lang="en-US" sz="1400" dirty="0" err="1"/>
-              <a:t>cuda</a:t>
-            </a:r>
-            <a:r>
-              <a:rPr lang="en-US" sz="1400" dirty="0"/>
-              <a:t> (GPU) device for accelerated training.</a:t>
-            </a:r>
-            <a:br>
-              <a:rPr lang="en-US" sz="1400" dirty="0"/>
-            </a:br>
-            <a:br>
-              <a:rPr lang="en-US" sz="1400" dirty="0"/>
-            </a:br>
-            <a:r>
-              <a:rPr lang="en-US" sz="1400" b="1" dirty="0"/>
-              <a:t>Weighted Loss Function: </a:t>
-            </a:r>
-            <a:r>
-              <a:rPr lang="en-US" sz="1400" dirty="0"/>
-              <a:t>crucial for handling the significant class imbalance.</a:t>
-            </a:r>
-            <a:br>
-              <a:rPr lang="en-US" sz="1400" dirty="0"/>
-            </a:br>
-            <a:br>
-              <a:rPr lang="en-US" sz="1400" b="1" dirty="0"/>
-            </a:br>
-            <a:r>
-              <a:rPr lang="en-US" sz="1400" b="1" dirty="0"/>
-              <a:t>Optimizer: The </a:t>
-            </a:r>
-            <a:r>
-              <a:rPr lang="en-US" sz="1400" dirty="0"/>
-              <a:t>Adam optimizer was employed with a learning rate of 0.001 and </a:t>
-            </a:r>
-            <a:r>
-              <a:rPr lang="en-US" sz="1400" dirty="0" err="1"/>
-              <a:t>weight_decay</a:t>
-            </a:r>
-            <a:r>
-              <a:rPr lang="en-US" sz="1400" dirty="0"/>
-              <a:t>=1e-5 to prevent overfitting.</a:t>
-            </a:r>
-            <a:br>
-              <a:rPr lang="en-US" sz="1400" dirty="0"/>
-            </a:br>
-            <a:br>
-              <a:rPr lang="en-US" sz="1400" dirty="0"/>
-            </a:br>
-            <a:r>
-              <a:rPr lang="en-US" sz="1400" b="1" dirty="0"/>
-              <a:t>Training Loop: </a:t>
-            </a:r>
-            <a:r>
-              <a:rPr lang="en-US" sz="1400" dirty="0"/>
-              <a:t>each epoch involved iterating through the </a:t>
-            </a:r>
-            <a:r>
-              <a:rPr lang="en-US" sz="1400" dirty="0" err="1"/>
-              <a:t>train_loader</a:t>
-            </a:r>
-            <a:r>
-              <a:rPr lang="en-US" sz="1400" dirty="0"/>
-              <a:t>, performing forward pass, calculating the weighted loss, backpropagating gradients, and updating model parameters.</a:t>
-            </a:r>
-            <a:br>
-              <a:rPr lang="en-US" sz="1400" dirty="0"/>
-            </a:br>
-            <a:br>
-              <a:rPr lang="en-US" sz="1400" dirty="0"/>
-            </a:br>
-            <a:r>
-              <a:rPr lang="en-US" sz="1400" b="1" dirty="0"/>
-              <a:t>Validation Loop: </a:t>
-            </a:r>
-            <a:r>
-              <a:rPr lang="en-US" sz="1400" dirty="0"/>
-              <a:t>after each epoch, the model was evaluated on the </a:t>
-            </a:r>
-            <a:r>
-              <a:rPr lang="en-US" sz="1400" dirty="0" err="1"/>
-              <a:t>test_loader</a:t>
-            </a:r>
-            <a:r>
-              <a:rPr lang="en-US" sz="1400" dirty="0"/>
-              <a:t> to monitor performance on unseen data.</a:t>
-            </a:r>
-            <a:br>
-              <a:rPr lang="en-US" sz="1400" dirty="0"/>
-            </a:br>
-            <a:br>
-              <a:rPr lang="en-US" sz="1400" dirty="0"/>
-            </a:br>
-            <a:r>
-              <a:rPr lang="en-US" sz="1400" dirty="0"/>
-              <a:t>Metrics like accuracy and AUC score were calculated to assess generalization ability.</a:t>
-            </a:r>
-            <a:br>
-              <a:rPr lang="en-US" dirty="0"/>
-            </a:br>
-            <a:br>
-              <a:rPr lang="fr-FR" dirty="0"/>
-            </a:br>
-            <a:br>
-              <a:rPr lang="en-US" dirty="0"/>
-            </a:br>
-            <a:br>
-              <a:rPr lang="en-US" sz="1600" dirty="0"/>
-            </a:br>
-            <a:br>
-              <a:rPr lang="en-US" dirty="0"/>
-            </a:br>
-            <a:br>
-              <a:rPr lang="fr-FR" sz="1600" dirty="0"/>
-            </a:br>
-            <a:br>
-              <a:rPr lang="fr-FR" dirty="0"/>
-            </a:br>
-            <a:endParaRPr lang="en-US" sz="1600" dirty="0"/>
-          </a:p>
-        </p:txBody>
-      </p:sp>
-    </p:spTree>
-    <p:extLst>
-      <p:ext uri="{BB962C8B-B14F-4D97-AF65-F5344CB8AC3E}">
-        <p14:creationId xmlns:p14="http://schemas.microsoft.com/office/powerpoint/2010/main" val="1601228616"/>
-      </p:ext>
-    </p:extLst>
-  </p:cSld>
-  <p:clrMapOvr>
-    <a:masterClrMapping/>
-  </p:clrMapOvr>
-</p:sld>
-</file>
-
-<file path=ppt/slides/slide12.xml><?xml version="1.0" encoding="utf-8"?>
-<p:sld xmlns:a="http://schemas.openxmlformats.org/drawingml/2006/main" xmlns:r="http://schemas.openxmlformats.org/officeDocument/2006/relationships" xmlns:p="http://schemas.openxmlformats.org/presentationml/2006/main">
-  <p:cSld>
-    <p:spTree>
-      <p:nvGrpSpPr>
-        <p:cNvPr id="1" name="Shape 80">
-          <a:extLst>
-            <a:ext uri="{FF2B5EF4-FFF2-40B4-BE49-F238E27FC236}">
-              <a16:creationId xmlns:a16="http://schemas.microsoft.com/office/drawing/2014/main" id="{ED642B1F-86B2-60A5-451B-100199CED629}"/>
-            </a:ext>
-          </a:extLst>
-        </p:cNvPr>
-        <p:cNvGrpSpPr/>
-        <p:nvPr/>
-      </p:nvGrpSpPr>
-      <p:grpSpPr>
-        <a:xfrm>
-          <a:off x="0" y="0"/>
-          <a:ext cx="0" cy="0"/>
-          <a:chOff x="0" y="0"/>
-          <a:chExt cx="0" cy="0"/>
-        </a:xfrm>
-      </p:grpSpPr>
-      <p:sp>
-        <p:nvSpPr>
-          <p:cNvPr id="81" name="Google Shape;81;p16">
-            <a:extLst>
-              <a:ext uri="{FF2B5EF4-FFF2-40B4-BE49-F238E27FC236}">
-                <a16:creationId xmlns:a16="http://schemas.microsoft.com/office/drawing/2014/main" id="{66300018-435D-F945-6779-2C2631A5C23F}"/>
-              </a:ext>
-            </a:extLst>
-          </p:cNvPr>
-          <p:cNvSpPr/>
-          <p:nvPr/>
-        </p:nvSpPr>
-        <p:spPr>
-          <a:xfrm>
-            <a:off x="5499" y="-17775"/>
-            <a:ext cx="3520625" cy="5161200"/>
-          </a:xfrm>
-          <a:prstGeom prst="rect">
-            <a:avLst/>
-          </a:prstGeom>
-          <a:solidFill>
-            <a:srgbClr val="C3FFFC"/>
-          </a:solidFill>
-          <a:ln>
-            <a:noFill/>
-          </a:ln>
-        </p:spPr>
-        <p:txBody>
-          <a:bodyPr spcFirstLastPara="1" wrap="square" lIns="91425" tIns="91425" rIns="91425" bIns="91425" anchor="ctr" anchorCtr="0">
-            <a:noAutofit/>
-          </a:bodyPr>
-          <a:lstStyle/>
-          <a:p>
-            <a:pPr marL="0" marR="0" lvl="0" indent="0" algn="l" rtl="0">
-              <a:lnSpc>
-                <a:spcPct val="100000"/>
-              </a:lnSpc>
-              <a:spcBef>
-                <a:spcPts val="0"/>
-              </a:spcBef>
-              <a:spcAft>
-                <a:spcPts val="0"/>
-              </a:spcAft>
-              <a:buClr>
-                <a:srgbClr val="000000"/>
-              </a:buClr>
-              <a:buSzPts val="1400"/>
-              <a:buFont typeface="Arial"/>
-              <a:buNone/>
-            </a:pPr>
-            <a:endParaRPr sz="1400" b="0" i="0" u="none" strike="noStrike" cap="none">
-              <a:solidFill>
-                <a:srgbClr val="000000"/>
-              </a:solidFill>
-              <a:latin typeface="Arial"/>
-              <a:ea typeface="Arial"/>
-              <a:cs typeface="Arial"/>
-              <a:sym typeface="Arial"/>
-            </a:endParaRPr>
-          </a:p>
-        </p:txBody>
-      </p:sp>
-      <p:sp>
-        <p:nvSpPr>
-          <p:cNvPr id="82" name="Google Shape;82;p16">
-            <a:extLst>
-              <a:ext uri="{FF2B5EF4-FFF2-40B4-BE49-F238E27FC236}">
-                <a16:creationId xmlns:a16="http://schemas.microsoft.com/office/drawing/2014/main" id="{D4136558-C25D-9E12-F881-F17613D060B8}"/>
-              </a:ext>
-            </a:extLst>
-          </p:cNvPr>
-          <p:cNvSpPr txBox="1">
-            <a:spLocks noGrp="1"/>
-          </p:cNvSpPr>
-          <p:nvPr>
-            <p:ph type="title"/>
-          </p:nvPr>
-        </p:nvSpPr>
-        <p:spPr>
-          <a:xfrm>
-            <a:off x="365330" y="1369383"/>
-            <a:ext cx="2988031" cy="1857766"/>
-          </a:xfrm>
-          <a:prstGeom prst="rect">
-            <a:avLst/>
-          </a:prstGeom>
-          <a:noFill/>
-          <a:ln>
-            <a:noFill/>
-          </a:ln>
-        </p:spPr>
-        <p:txBody>
-          <a:bodyPr spcFirstLastPara="1" wrap="square" lIns="91425" tIns="91425" rIns="91425" bIns="91425" anchor="t" anchorCtr="0">
-            <a:noAutofit/>
-          </a:bodyPr>
-          <a:lstStyle/>
-          <a:p>
-            <a:r>
-              <a:rPr lang="fr-FR" b="1" dirty="0"/>
-              <a:t>Evaluation et comparaison des modèles</a:t>
-            </a:r>
-            <a:br>
-              <a:rPr lang="fr-FR" dirty="0"/>
-            </a:br>
-            <a:br>
-              <a:rPr lang="en-US" dirty="0"/>
-            </a:br>
-            <a:br>
-              <a:rPr lang="fr-FR" dirty="0"/>
-            </a:br>
-            <a:br>
-              <a:rPr lang="en-US" dirty="0"/>
-            </a:br>
-            <a:br>
-              <a:rPr lang="fr-FR" dirty="0"/>
-            </a:br>
-            <a:br>
-              <a:rPr lang="fr-FR" b="1" dirty="0"/>
-            </a:br>
-            <a:br>
-              <a:rPr lang="fr" sz="2400" dirty="0">
-                <a:solidFill>
-                  <a:srgbClr val="015955"/>
-                </a:solidFill>
-                <a:latin typeface="Inter"/>
-                <a:ea typeface="Inter"/>
-                <a:cs typeface="Inter"/>
-                <a:sym typeface="Inter"/>
-              </a:rPr>
-            </a:br>
-            <a:br>
-              <a:rPr lang="fr" sz="2400" dirty="0">
-                <a:solidFill>
-                  <a:srgbClr val="015955"/>
-                </a:solidFill>
-                <a:latin typeface="Inter"/>
-                <a:ea typeface="Inter"/>
-                <a:cs typeface="Inter"/>
-                <a:sym typeface="Inter"/>
-              </a:rPr>
-            </a:br>
-            <a:endParaRPr sz="2400" dirty="0">
-              <a:solidFill>
-                <a:srgbClr val="015955"/>
-              </a:solidFill>
-              <a:latin typeface="Inter"/>
-              <a:ea typeface="Inter"/>
-              <a:cs typeface="Inter"/>
-              <a:sym typeface="Inter"/>
-            </a:endParaRPr>
-          </a:p>
-        </p:txBody>
-      </p:sp>
-      <p:pic>
-        <p:nvPicPr>
-          <p:cNvPr id="83" name="Google Shape;83;p16">
-            <a:extLst>
-              <a:ext uri="{FF2B5EF4-FFF2-40B4-BE49-F238E27FC236}">
-                <a16:creationId xmlns:a16="http://schemas.microsoft.com/office/drawing/2014/main" id="{043A57F9-4A1F-D430-FEA6-30310DBE76BE}"/>
-              </a:ext>
-            </a:extLst>
-          </p:cNvPr>
-          <p:cNvPicPr preferRelativeResize="0"/>
-          <p:nvPr/>
-        </p:nvPicPr>
-        <p:blipFill rotWithShape="1">
-          <a:blip r:embed="rId3">
-            <a:alphaModFix/>
-          </a:blip>
-          <a:srcRect/>
-          <a:stretch/>
-        </p:blipFill>
-        <p:spPr>
-          <a:xfrm>
-            <a:off x="463375" y="482852"/>
-            <a:ext cx="576900" cy="385904"/>
-          </a:xfrm>
-          <a:prstGeom prst="rect">
-            <a:avLst/>
-          </a:prstGeom>
-          <a:noFill/>
-          <a:ln>
-            <a:noFill/>
-          </a:ln>
-        </p:spPr>
-      </p:pic>
-      <p:sp>
-        <p:nvSpPr>
-          <p:cNvPr id="84" name="Google Shape;84;p16">
-            <a:extLst>
-              <a:ext uri="{FF2B5EF4-FFF2-40B4-BE49-F238E27FC236}">
-                <a16:creationId xmlns:a16="http://schemas.microsoft.com/office/drawing/2014/main" id="{184E04A7-6DCB-FAF8-0D66-F4C55D80D0DE}"/>
-              </a:ext>
-            </a:extLst>
-          </p:cNvPr>
-          <p:cNvSpPr txBox="1">
-            <a:spLocks noGrp="1"/>
-          </p:cNvSpPr>
-          <p:nvPr>
-            <p:ph type="ctrTitle" idx="4294967295"/>
-          </p:nvPr>
-        </p:nvSpPr>
-        <p:spPr>
-          <a:xfrm>
-            <a:off x="3588119" y="579248"/>
-            <a:ext cx="5455142" cy="4488698"/>
-          </a:xfrm>
-          <a:prstGeom prst="rect">
-            <a:avLst/>
-          </a:prstGeom>
-          <a:noFill/>
-          <a:ln>
-            <a:noFill/>
-          </a:ln>
-        </p:spPr>
-        <p:txBody>
-          <a:bodyPr spcFirstLastPara="1" wrap="square" lIns="91425" tIns="91425" rIns="91425" bIns="91425" anchor="t" anchorCtr="0">
-            <a:noAutofit/>
-          </a:bodyPr>
-          <a:lstStyle/>
-          <a:p>
-            <a:r>
-              <a:rPr lang="fr-FR" sz="1400" b="1" noProof="0" dirty="0" err="1"/>
-              <a:t>Ultra-Simple</a:t>
-            </a:r>
-            <a:r>
-              <a:rPr lang="fr-FR" sz="1400" b="1" noProof="0" dirty="0"/>
-              <a:t> NN</a:t>
-            </a:r>
-            <a:br>
-              <a:rPr lang="fr-FR" sz="1400" b="1" noProof="0" dirty="0"/>
-            </a:br>
-            <a:br>
-              <a:rPr lang="fr-FR" sz="1400" b="1" noProof="0" dirty="0"/>
-            </a:br>
-            <a:r>
-              <a:rPr lang="fr-FR" sz="1400" noProof="0" dirty="0"/>
-              <a:t>Sachant que les deux modèles sont efficaces, il vaut mieux choisir le modèle plus simple: </a:t>
-            </a:r>
-            <a:r>
-              <a:rPr lang="fr-FR" sz="1400" b="1" noProof="0" dirty="0" err="1"/>
-              <a:t>Ultra-Simple</a:t>
-            </a:r>
-            <a:r>
-              <a:rPr lang="fr-FR" sz="1400" b="1" noProof="0" dirty="0"/>
-              <a:t> Neural Network </a:t>
-            </a:r>
-            <a:r>
-              <a:rPr lang="fr-FR" sz="1400" noProof="0" dirty="0"/>
-              <a:t>car il compte deux fois moins de paramètres tout en obtenant les résultats comparables ce qui allège les ressources de calcul pour la détection des spams.</a:t>
-            </a:r>
-            <a:br>
-              <a:rPr lang="fr-FR" sz="1400" noProof="0" dirty="0"/>
-            </a:br>
-            <a:br>
-              <a:rPr lang="fr-FR" sz="1600" noProof="0" dirty="0"/>
-            </a:br>
-            <a:br>
-              <a:rPr lang="fr-FR" noProof="0" dirty="0"/>
-            </a:br>
-            <a:br>
-              <a:rPr lang="fr-FR" sz="1600" noProof="0" dirty="0"/>
-            </a:br>
-            <a:br>
-              <a:rPr lang="fr-FR" noProof="0" dirty="0"/>
-            </a:br>
-            <a:endParaRPr lang="fr-FR" sz="1600" noProof="0" dirty="0"/>
-          </a:p>
-        </p:txBody>
-      </p:sp>
-      <p:pic>
-        <p:nvPicPr>
-          <p:cNvPr id="3" name="Image 2" descr="Une image contenant texte, capture d’écran, diagramme, Rectangle&#10;&#10;Le contenu généré par l’IA peut être incorrect.">
-            <a:extLst>
-              <a:ext uri="{FF2B5EF4-FFF2-40B4-BE49-F238E27FC236}">
-                <a16:creationId xmlns:a16="http://schemas.microsoft.com/office/drawing/2014/main" id="{C702E82C-DF40-71D0-AE1B-AB16CE574622}"/>
-              </a:ext>
-            </a:extLst>
-          </p:cNvPr>
-          <p:cNvPicPr>
-            <a:picLocks noChangeAspect="1"/>
-          </p:cNvPicPr>
-          <p:nvPr/>
-        </p:nvPicPr>
-        <p:blipFill>
-          <a:blip r:embed="rId4"/>
-          <a:stretch>
-            <a:fillRect/>
-          </a:stretch>
-        </p:blipFill>
-        <p:spPr>
-          <a:xfrm>
-            <a:off x="3798512" y="2298266"/>
-            <a:ext cx="2049308" cy="1942716"/>
-          </a:xfrm>
-          <a:prstGeom prst="rect">
-            <a:avLst/>
-          </a:prstGeom>
-        </p:spPr>
-      </p:pic>
-      <p:pic>
-        <p:nvPicPr>
-          <p:cNvPr id="5" name="Image 4" descr="Une image contenant texte, capture d’écran, diagramme, Rectangle&#10;&#10;Le contenu généré par l’IA peut être incorrect.">
-            <a:extLst>
-              <a:ext uri="{FF2B5EF4-FFF2-40B4-BE49-F238E27FC236}">
-                <a16:creationId xmlns:a16="http://schemas.microsoft.com/office/drawing/2014/main" id="{4F46F44E-8250-E270-299C-6F5BD20E1F4E}"/>
-              </a:ext>
-            </a:extLst>
-          </p:cNvPr>
-          <p:cNvPicPr>
-            <a:picLocks noChangeAspect="1"/>
-          </p:cNvPicPr>
-          <p:nvPr/>
-        </p:nvPicPr>
-        <p:blipFill>
-          <a:blip r:embed="rId5"/>
-          <a:stretch>
-            <a:fillRect/>
-          </a:stretch>
-        </p:blipFill>
-        <p:spPr>
-          <a:xfrm>
-            <a:off x="6192760" y="2199020"/>
-            <a:ext cx="2049308" cy="1999487"/>
-          </a:xfrm>
-          <a:prstGeom prst="rect">
-            <a:avLst/>
-          </a:prstGeom>
-        </p:spPr>
-      </p:pic>
-    </p:spTree>
-    <p:extLst>
-      <p:ext uri="{BB962C8B-B14F-4D97-AF65-F5344CB8AC3E}">
-        <p14:creationId xmlns:p14="http://schemas.microsoft.com/office/powerpoint/2010/main" val="2507890807"/>
-      </p:ext>
-    </p:extLst>
-  </p:cSld>
-  <p:clrMapOvr>
-    <a:masterClrMapping/>
-  </p:clrMapOvr>
-</p:sld>
-</file>
-
-<file path=ppt/slides/slide13.xml><?xml version="1.0" encoding="utf-8"?>
-<p:sld xmlns:a="http://schemas.openxmlformats.org/drawingml/2006/main" xmlns:r="http://schemas.openxmlformats.org/officeDocument/2006/relationships" xmlns:p="http://schemas.openxmlformats.org/presentationml/2006/main">
-  <p:cSld>
-    <p:spTree>
-      <p:nvGrpSpPr>
-        <p:cNvPr id="1" name="Shape 80">
-          <a:extLst>
-            <a:ext uri="{FF2B5EF4-FFF2-40B4-BE49-F238E27FC236}">
               <a16:creationId xmlns:a16="http://schemas.microsoft.com/office/drawing/2014/main" id="{C32A60FE-CE44-2D5D-F927-68E8F986E124}"/>
             </a:ext>
           </a:extLst>
@@ -10055,7 +8428,7 @@
 </p:sld>
 </file>
 
-<file path=ppt/slides/slide14.xml><?xml version="1.0" encoding="utf-8"?>
+<file path=ppt/slides/slide11.xml><?xml version="1.0" encoding="utf-8"?>
 <p:sld xmlns:a="http://schemas.openxmlformats.org/drawingml/2006/main" xmlns:r="http://schemas.openxmlformats.org/officeDocument/2006/relationships" xmlns:p="http://schemas.openxmlformats.org/presentationml/2006/main">
   <p:cSld>
     <p:spTree>
@@ -10271,8 +8644,8 @@
         </p:nvSpPr>
         <p:spPr>
           <a:xfrm>
-            <a:off x="3872289" y="868756"/>
-            <a:ext cx="4865613" cy="3703244"/>
+            <a:off x="3872289" y="957915"/>
+            <a:ext cx="4865613" cy="3478913"/>
           </a:xfrm>
           <a:prstGeom prst="rect">
             <a:avLst/>
@@ -10315,28 +8688,21 @@
             </a:br>
             <a:r>
               <a:rPr lang="fr-FR" sz="1800" noProof="0" dirty="0"/>
-              <a:t>3. Fine-tuning du modèle de Sentence Transformers </a:t>
+              <a:t>3. Ingénieries des variables plus poussées</a:t>
             </a:r>
             <a:br>
               <a:rPr lang="fr-FR" sz="1800" noProof="0" dirty="0"/>
             </a:br>
             <a:r>
               <a:rPr lang="fr-FR" sz="1800" noProof="0" dirty="0"/>
-              <a:t>4. Ingénieries des variables plus poussées</a:t>
+              <a:t>4. Expansion du jeu de données (une autre langue)</a:t>
             </a:r>
             <a:br>
               <a:rPr lang="fr-FR" sz="1800" noProof="0" dirty="0"/>
             </a:br>
             <a:r>
               <a:rPr lang="fr-FR" sz="1800" noProof="0" dirty="0"/>
-              <a:t>5. Expansion du jeu de données </a:t>
-            </a:r>
-            <a:br>
-              <a:rPr lang="fr-FR" sz="1800" noProof="0" dirty="0"/>
-            </a:br>
-            <a:r>
-              <a:rPr lang="fr-FR" sz="1800" noProof="0" dirty="0"/>
-              <a:t>6. Déploiement du modèle pour utilisation en temps réel</a:t>
+              <a:t>5. Déploiement du modèle pour utilisation en temps réel</a:t>
             </a:r>
             <a:br>
               <a:rPr lang="fr-FR" sz="1600" noProof="0" dirty="0"/>
@@ -10400,7 +8766,7 @@
 </p:sld>
 </file>
 
-<file path=ppt/slides/slide15.xml><?xml version="1.0" encoding="utf-8"?>
+<file path=ppt/slides/slide12.xml><?xml version="1.0" encoding="utf-8"?>
 <p:sld xmlns:a="http://schemas.openxmlformats.org/drawingml/2006/main" xmlns:r="http://schemas.openxmlformats.org/officeDocument/2006/relationships" xmlns:p="http://schemas.openxmlformats.org/presentationml/2006/main">
   <p:cSld>
     <p:spTree>
@@ -10503,8 +8869,8 @@
         </p:nvSpPr>
         <p:spPr>
           <a:xfrm>
-            <a:off x="406097" y="1030187"/>
-            <a:ext cx="3088771" cy="1647699"/>
+            <a:off x="549937" y="1379931"/>
+            <a:ext cx="2361676" cy="1084860"/>
           </a:xfrm>
           <a:prstGeom prst="rect">
             <a:avLst/>
@@ -10775,7 +9141,7 @@
 </p:sld>
 </file>
 
-<file path=ppt/slides/slide16.xml><?xml version="1.0" encoding="utf-8"?>
+<file path=ppt/slides/slide13.xml><?xml version="1.0" encoding="utf-8"?>
 <p:sld xmlns:a="http://schemas.openxmlformats.org/drawingml/2006/main" xmlns:r="http://schemas.openxmlformats.org/officeDocument/2006/relationships" xmlns:p="http://schemas.openxmlformats.org/presentationml/2006/main">
   <p:cSld>
     <p:bg>
@@ -10999,7 +9365,7 @@
 </p:sld>
 </file>
 
-<file path=ppt/slides/slide17.xml><?xml version="1.0" encoding="utf-8"?>
+<file path=ppt/slides/slide14.xml><?xml version="1.0" encoding="utf-8"?>
 <p:sld xmlns:a="http://schemas.openxmlformats.org/drawingml/2006/main" xmlns:r="http://schemas.openxmlformats.org/officeDocument/2006/relationships" xmlns:p="http://schemas.openxmlformats.org/presentationml/2006/main">
   <p:cSld>
     <p:bg>
@@ -11241,8 +9607,8 @@
         </p:nvSpPr>
         <p:spPr>
           <a:xfrm>
-            <a:off x="528599" y="1199357"/>
-            <a:ext cx="7189328" cy="3116611"/>
+            <a:off x="463375" y="868756"/>
+            <a:ext cx="7189328" cy="3850073"/>
           </a:xfrm>
           <a:prstGeom prst="rect">
             <a:avLst/>
@@ -11302,6 +9668,34 @@
             <a:r>
               <a:rPr lang="fr-FR" dirty="0"/>
               <a:t>(apprentissage profond)</a:t>
+            </a:r>
+            <a:br>
+              <a:rPr lang="fr-FR" dirty="0"/>
+            </a:br>
+            <a:br>
+              <a:rPr lang="fr-FR" dirty="0"/>
+            </a:br>
+            <a:r>
+              <a:rPr lang="fr-FR" sz="1800" dirty="0"/>
+              <a:t>Lien vers le dépôt sur </a:t>
+            </a:r>
+            <a:r>
+              <a:rPr lang="fr-FR" sz="1800" dirty="0" err="1"/>
+              <a:t>Github</a:t>
+            </a:r>
+            <a:r>
+              <a:rPr lang="fr-FR" sz="1800" dirty="0"/>
+              <a:t>: </a:t>
+            </a:r>
+            <a:r>
+              <a:rPr lang="fr-FR" sz="1800" dirty="0">
+                <a:hlinkClick r:id="rId3"/>
+              </a:rPr>
+              <a:t>https://github.com/AgaHei/Spam-Detector</a:t>
+            </a:r>
+            <a:r>
+              <a:rPr lang="fr-FR" sz="1800" dirty="0"/>
+              <a:t> </a:t>
             </a:r>
             <a:br>
               <a:rPr lang="fr" sz="4800" dirty="0">
@@ -11344,7 +9738,7 @@
           <p:nvPr/>
         </p:nvPicPr>
         <p:blipFill>
-          <a:blip r:embed="rId3">
+          <a:blip r:embed="rId4">
             <a:alphaModFix/>
           </a:blip>
           <a:stretch>
@@ -11380,7 +9774,7 @@
           <p:nvPr/>
         </p:nvPicPr>
         <p:blipFill>
-          <a:blip r:embed="rId4">
+          <a:blip r:embed="rId5">
             <a:extLst>
               <a:ext uri="{28A0092B-C50C-407E-A947-70E740481C1C}">
                 <a14:useLocalDpi xmlns:a14="http://schemas.microsoft.com/office/drawing/2010/main" val="0"/>
@@ -11394,7 +9788,7 @@
         </p:blipFill>
         <p:spPr bwMode="auto">
           <a:xfrm>
-            <a:off x="6591256" y="2634696"/>
+            <a:off x="6696452" y="1744572"/>
             <a:ext cx="2253343" cy="2253343"/>
           </a:xfrm>
           <a:prstGeom prst="rect">
@@ -11464,10 +9858,10 @@
           <a:p>
             <a:pPr lvl="0"/>
             <a:r>
-              <a:rPr lang="fr-FR" sz="2400" noProof="0" dirty="0"/>
+              <a:rPr lang="fr-FR" sz="2400" b="1" noProof="0" dirty="0"/>
               <a:t>Objectif du projet</a:t>
             </a:r>
-            <a:endParaRPr lang="fr-FR" sz="2500" noProof="0" dirty="0">
+            <a:endParaRPr lang="fr-FR" sz="2500" b="1" noProof="0" dirty="0">
               <a:solidFill>
                 <a:srgbClr val="0E3449"/>
               </a:solidFill>
@@ -11514,7 +9908,23 @@
                   <a:schemeClr val="tx1"/>
                 </a:solidFill>
               </a:rPr>
-              <a:t>Développer un détecteur de spam automatique en utilisant des techniques d’apprentissage profond avancées, exploiter l’apprentissage</a:t>
+              <a:t>Développer un </a:t>
+            </a:r>
+            <a:r>
+              <a:rPr lang="fr-FR" sz="2400" b="1" noProof="0" dirty="0">
+                <a:solidFill>
+                  <a:schemeClr val="tx1"/>
+                </a:solidFill>
+              </a:rPr>
+              <a:t>détecteur de spam automatique </a:t>
+            </a:r>
+            <a:r>
+              <a:rPr lang="fr-FR" sz="2400" noProof="0" dirty="0">
+                <a:solidFill>
+                  <a:schemeClr val="tx1"/>
+                </a:solidFill>
+              </a:rPr>
+              <a:t>en utilisant des techniques d’apprentissage profond avancées, exploiter l’apprentissage</a:t>
             </a:r>
             <a:r>
               <a:rPr lang="fr-FR" sz="2400" dirty="0">
@@ -12016,345 +10426,6 @@
 </file>
 
 <file path=ppt/slides/slide5.xml><?xml version="1.0" encoding="utf-8"?>
-<p:sld xmlns:a="http://schemas.openxmlformats.org/drawingml/2006/main" xmlns:r="http://schemas.openxmlformats.org/officeDocument/2006/relationships" xmlns:p="http://schemas.openxmlformats.org/presentationml/2006/main" show="0">
-  <p:cSld>
-    <p:spTree>
-      <p:nvGrpSpPr>
-        <p:cNvPr id="1" name="Shape 80">
-          <a:extLst>
-            <a:ext uri="{FF2B5EF4-FFF2-40B4-BE49-F238E27FC236}">
-              <a16:creationId xmlns:a16="http://schemas.microsoft.com/office/drawing/2014/main" id="{A8A5D7D1-F001-0176-41AE-652C7D7C9DFC}"/>
-            </a:ext>
-          </a:extLst>
-        </p:cNvPr>
-        <p:cNvGrpSpPr/>
-        <p:nvPr/>
-      </p:nvGrpSpPr>
-      <p:grpSpPr>
-        <a:xfrm>
-          <a:off x="0" y="0"/>
-          <a:ext cx="0" cy="0"/>
-          <a:chOff x="0" y="0"/>
-          <a:chExt cx="0" cy="0"/>
-        </a:xfrm>
-      </p:grpSpPr>
-      <p:sp>
-        <p:nvSpPr>
-          <p:cNvPr id="81" name="Google Shape;81;p16">
-            <a:extLst>
-              <a:ext uri="{FF2B5EF4-FFF2-40B4-BE49-F238E27FC236}">
-                <a16:creationId xmlns:a16="http://schemas.microsoft.com/office/drawing/2014/main" id="{7FFC7DC1-B63D-89A9-0E71-7A081E9C4BD5}"/>
-              </a:ext>
-            </a:extLst>
-          </p:cNvPr>
-          <p:cNvSpPr/>
-          <p:nvPr/>
-        </p:nvSpPr>
-        <p:spPr>
-          <a:xfrm>
-            <a:off x="5500" y="-17775"/>
-            <a:ext cx="3691106" cy="5161200"/>
-          </a:xfrm>
-          <a:prstGeom prst="rect">
-            <a:avLst/>
-          </a:prstGeom>
-          <a:solidFill>
-            <a:srgbClr val="C3FFFC"/>
-          </a:solidFill>
-          <a:ln>
-            <a:noFill/>
-          </a:ln>
-        </p:spPr>
-        <p:txBody>
-          <a:bodyPr spcFirstLastPara="1" wrap="square" lIns="91425" tIns="91425" rIns="91425" bIns="91425" anchor="ctr" anchorCtr="0">
-            <a:noAutofit/>
-          </a:bodyPr>
-          <a:lstStyle/>
-          <a:p>
-            <a:pPr marL="0" marR="0" lvl="0" indent="0" algn="l" rtl="0">
-              <a:lnSpc>
-                <a:spcPct val="100000"/>
-              </a:lnSpc>
-              <a:spcBef>
-                <a:spcPts val="0"/>
-              </a:spcBef>
-              <a:spcAft>
-                <a:spcPts val="0"/>
-              </a:spcAft>
-              <a:buClr>
-                <a:srgbClr val="000000"/>
-              </a:buClr>
-              <a:buSzPts val="1400"/>
-              <a:buFont typeface="Arial"/>
-              <a:buNone/>
-            </a:pPr>
-            <a:endParaRPr sz="1400" b="0" i="0" u="none" strike="noStrike" cap="none">
-              <a:solidFill>
-                <a:srgbClr val="000000"/>
-              </a:solidFill>
-              <a:latin typeface="Arial"/>
-              <a:ea typeface="Arial"/>
-              <a:cs typeface="Arial"/>
-              <a:sym typeface="Arial"/>
-            </a:endParaRPr>
-          </a:p>
-        </p:txBody>
-      </p:sp>
-      <p:sp>
-        <p:nvSpPr>
-          <p:cNvPr id="82" name="Google Shape;82;p16">
-            <a:extLst>
-              <a:ext uri="{FF2B5EF4-FFF2-40B4-BE49-F238E27FC236}">
-                <a16:creationId xmlns:a16="http://schemas.microsoft.com/office/drawing/2014/main" id="{AD11FFD6-8681-77E2-B818-342D4E50E44C}"/>
-              </a:ext>
-            </a:extLst>
-          </p:cNvPr>
-          <p:cNvSpPr txBox="1">
-            <a:spLocks noGrp="1"/>
-          </p:cNvSpPr>
-          <p:nvPr>
-            <p:ph type="title"/>
-          </p:nvPr>
-        </p:nvSpPr>
-        <p:spPr>
-          <a:xfrm>
-            <a:off x="390598" y="1138675"/>
-            <a:ext cx="3306007" cy="3458100"/>
-          </a:xfrm>
-          <a:prstGeom prst="rect">
-            <a:avLst/>
-          </a:prstGeom>
-          <a:noFill/>
-          <a:ln>
-            <a:noFill/>
-          </a:ln>
-        </p:spPr>
-        <p:txBody>
-          <a:bodyPr spcFirstLastPara="1" wrap="square" lIns="91425" tIns="91425" rIns="91425" bIns="91425" anchor="t" anchorCtr="0">
-            <a:noAutofit/>
-          </a:bodyPr>
-          <a:lstStyle/>
-          <a:p>
-            <a:r>
-              <a:rPr lang="en-US" b="1" dirty="0"/>
-              <a:t>Exploratory Data Analysis (EDA) &amp; Insights</a:t>
-            </a:r>
-            <a:br>
-              <a:rPr lang="en-US" b="1" dirty="0"/>
-            </a:br>
-            <a:br>
-              <a:rPr lang="en-US" b="1" dirty="0"/>
-            </a:br>
-            <a:r>
-              <a:rPr lang="en-US" dirty="0"/>
-              <a:t>Key Findings</a:t>
-            </a:r>
-            <a:br>
-              <a:rPr lang="en-US" dirty="0"/>
-            </a:br>
-            <a:br>
-              <a:rPr lang="en-US" sz="2400" dirty="0"/>
-            </a:br>
-            <a:br>
-              <a:rPr lang="fr" sz="2400" dirty="0">
-                <a:solidFill>
-                  <a:srgbClr val="015955"/>
-                </a:solidFill>
-                <a:latin typeface="Inter"/>
-                <a:ea typeface="Inter"/>
-                <a:cs typeface="Inter"/>
-                <a:sym typeface="Inter"/>
-              </a:rPr>
-            </a:br>
-            <a:br>
-              <a:rPr lang="fr" sz="2400" dirty="0">
-                <a:solidFill>
-                  <a:srgbClr val="015955"/>
-                </a:solidFill>
-                <a:latin typeface="Inter"/>
-                <a:ea typeface="Inter"/>
-                <a:cs typeface="Inter"/>
-                <a:sym typeface="Inter"/>
-              </a:rPr>
-            </a:br>
-            <a:endParaRPr sz="2400" dirty="0">
-              <a:solidFill>
-                <a:srgbClr val="015955"/>
-              </a:solidFill>
-              <a:latin typeface="Inter"/>
-              <a:ea typeface="Inter"/>
-              <a:cs typeface="Inter"/>
-              <a:sym typeface="Inter"/>
-            </a:endParaRPr>
-          </a:p>
-        </p:txBody>
-      </p:sp>
-      <p:pic>
-        <p:nvPicPr>
-          <p:cNvPr id="83" name="Google Shape;83;p16">
-            <a:extLst>
-              <a:ext uri="{FF2B5EF4-FFF2-40B4-BE49-F238E27FC236}">
-                <a16:creationId xmlns:a16="http://schemas.microsoft.com/office/drawing/2014/main" id="{60D7D562-0F34-DD17-FD35-4F73EEFBE3DB}"/>
-              </a:ext>
-            </a:extLst>
-          </p:cNvPr>
-          <p:cNvPicPr preferRelativeResize="0"/>
-          <p:nvPr/>
-        </p:nvPicPr>
-        <p:blipFill rotWithShape="1">
-          <a:blip r:embed="rId3">
-            <a:alphaModFix/>
-          </a:blip>
-          <a:srcRect/>
-          <a:stretch/>
-        </p:blipFill>
-        <p:spPr>
-          <a:xfrm>
-            <a:off x="463375" y="482852"/>
-            <a:ext cx="576900" cy="385904"/>
-          </a:xfrm>
-          <a:prstGeom prst="rect">
-            <a:avLst/>
-          </a:prstGeom>
-          <a:noFill/>
-          <a:ln>
-            <a:noFill/>
-          </a:ln>
-        </p:spPr>
-      </p:pic>
-      <p:sp>
-        <p:nvSpPr>
-          <p:cNvPr id="84" name="Google Shape;84;p16">
-            <a:extLst>
-              <a:ext uri="{FF2B5EF4-FFF2-40B4-BE49-F238E27FC236}">
-                <a16:creationId xmlns:a16="http://schemas.microsoft.com/office/drawing/2014/main" id="{58063B08-1C2E-B674-6B5A-1F7A688B758A}"/>
-              </a:ext>
-            </a:extLst>
-          </p:cNvPr>
-          <p:cNvSpPr txBox="1">
-            <a:spLocks noGrp="1"/>
-          </p:cNvSpPr>
-          <p:nvPr>
-            <p:ph type="ctrTitle" idx="4294967295"/>
-          </p:nvPr>
-        </p:nvSpPr>
-        <p:spPr>
-          <a:xfrm>
-            <a:off x="3696605" y="362272"/>
-            <a:ext cx="5315100" cy="4155483"/>
-          </a:xfrm>
-          <a:prstGeom prst="rect">
-            <a:avLst/>
-          </a:prstGeom>
-          <a:noFill/>
-          <a:ln>
-            <a:noFill/>
-          </a:ln>
-        </p:spPr>
-        <p:txBody>
-          <a:bodyPr spcFirstLastPara="1" wrap="square" lIns="91425" tIns="91425" rIns="91425" bIns="91425" anchor="t" anchorCtr="0">
-            <a:noAutofit/>
-          </a:bodyPr>
-          <a:lstStyle/>
-          <a:p>
-            <a:r>
-              <a:rPr lang="en-US" sz="1600" b="1" dirty="0"/>
-              <a:t>- Significant Class Imbalance:</a:t>
-            </a:r>
-            <a:br>
-              <a:rPr lang="en-US" sz="1600" dirty="0"/>
-            </a:br>
-            <a:r>
-              <a:rPr lang="en-US" sz="1600" dirty="0"/>
-              <a:t>Dataset has 5572 messages: 4825 'ham' (86.6%) and 747 'spam' (13.4%). </a:t>
-            </a:r>
-            <a:br>
-              <a:rPr lang="en-US" sz="1600" dirty="0"/>
-            </a:br>
-            <a:br>
-              <a:rPr lang="en-US" sz="1600" dirty="0"/>
-            </a:br>
-            <a:r>
-              <a:rPr lang="en-US" sz="1600" b="1" dirty="0"/>
-              <a:t>- Message Length Differences:</a:t>
-            </a:r>
-            <a:br>
-              <a:rPr lang="en-US" sz="1600" dirty="0"/>
-            </a:br>
-            <a:r>
-              <a:rPr lang="en-US" sz="1600" dirty="0"/>
-              <a:t>'Ham' messages are generally shorter </a:t>
-            </a:r>
-            <a:br>
-              <a:rPr lang="en-US" sz="1600" dirty="0"/>
-            </a:br>
-            <a:br>
-              <a:rPr lang="en-US" sz="1600" dirty="0"/>
-            </a:br>
-            <a:r>
-              <a:rPr lang="en-US" sz="1600" b="1" dirty="0"/>
-              <a:t>- Distinct Language Styles:</a:t>
-            </a:r>
-            <a:br>
-              <a:rPr lang="en-US" sz="1600" dirty="0"/>
-            </a:br>
-            <a:r>
-              <a:rPr lang="en-US" sz="1600" dirty="0"/>
-              <a:t>Ham: Often casual, uses slang, and personal tone. Spam: Characterized by formal, promotional, and urgent language.</a:t>
-            </a:r>
-            <a:br>
-              <a:rPr lang="en-US" sz="1600" dirty="0"/>
-            </a:br>
-            <a:br>
-              <a:rPr lang="en-US" sz="1600" dirty="0"/>
-            </a:br>
-            <a:r>
-              <a:rPr lang="en-US" sz="1600" b="1" dirty="0"/>
-              <a:t>- Vocabulary Patterns:</a:t>
-            </a:r>
-            <a:br>
-              <a:rPr lang="en-US" sz="1600" dirty="0"/>
-            </a:br>
-            <a:r>
-              <a:rPr lang="en-US" sz="1600" dirty="0"/>
-              <a:t>Spam Keywords: Frequent use of terms like "free", "win", "reward", "claim", "urgent", "offer" — classic indicators.</a:t>
-            </a:r>
-            <a:br>
-              <a:rPr lang="en-US" sz="1400" dirty="0"/>
-            </a:br>
-            <a:br>
-              <a:rPr lang="en-US" sz="1400" dirty="0"/>
-            </a:br>
-            <a:br>
-              <a:rPr lang="en-US" dirty="0"/>
-            </a:br>
-            <a:br>
-              <a:rPr lang="en-US" sz="1600" dirty="0"/>
-            </a:br>
-            <a:br>
-              <a:rPr lang="en-US" dirty="0"/>
-            </a:br>
-            <a:br>
-              <a:rPr lang="fr-FR" dirty="0"/>
-            </a:br>
-            <a:endParaRPr lang="en-US" sz="1600" dirty="0"/>
-          </a:p>
-        </p:txBody>
-      </p:sp>
-    </p:spTree>
-    <p:extLst>
-      <p:ext uri="{BB962C8B-B14F-4D97-AF65-F5344CB8AC3E}">
-        <p14:creationId xmlns:p14="http://schemas.microsoft.com/office/powerpoint/2010/main" val="1856429892"/>
-      </p:ext>
-    </p:extLst>
-  </p:cSld>
-  <p:clrMapOvr>
-    <a:masterClrMapping/>
-  </p:clrMapOvr>
-</p:sld>
-</file>
-
-<file path=ppt/slides/slide6.xml><?xml version="1.0" encoding="utf-8"?>
 <p:sld xmlns:a="http://schemas.openxmlformats.org/drawingml/2006/main" xmlns:r="http://schemas.openxmlformats.org/officeDocument/2006/relationships" xmlns:p="http://schemas.openxmlformats.org/presentationml/2006/main">
   <p:cSld>
     <p:spTree>
@@ -12767,7 +10838,7 @@
 </p:sld>
 </file>
 
-<file path=ppt/slides/slide7.xml><?xml version="1.0" encoding="utf-8"?>
+<file path=ppt/slides/slide6.xml><?xml version="1.0" encoding="utf-8"?>
 <p:sld xmlns:a="http://schemas.openxmlformats.org/drawingml/2006/main" xmlns:r="http://schemas.openxmlformats.org/officeDocument/2006/relationships" xmlns:p="http://schemas.openxmlformats.org/presentationml/2006/main">
   <p:cSld>
     <p:spTree>
@@ -13006,8 +11077,8 @@
         </p:nvSpPr>
         <p:spPr>
           <a:xfrm>
-            <a:off x="3740519" y="1141433"/>
-            <a:ext cx="5315100" cy="3425576"/>
+            <a:off x="3707517" y="697480"/>
+            <a:ext cx="4997675" cy="3969936"/>
           </a:xfrm>
           <a:prstGeom prst="rect">
             <a:avLst/>
@@ -13035,45 +11106,100 @@
             </a:br>
             <a:r>
               <a:rPr lang="fr-FR" sz="1800" noProof="0" dirty="0"/>
-              <a:t> - </a:t>
-            </a:r>
-            <a:r>
-              <a:rPr lang="fr-FR" sz="1800" noProof="0" dirty="0" err="1"/>
+              <a:t>- </a:t>
+            </a:r>
+            <a:r>
+              <a:rPr lang="fr-FR" sz="1800" b="1" noProof="0" dirty="0" err="1"/>
               <a:t>spam_keyword_count</a:t>
             </a:r>
-            <a:r>
+            <a:br>
               <a:rPr lang="fr-FR" sz="1800" noProof="0" dirty="0"/>
-              <a:t>: compte les occurrences des mots clés attribués aux spams</a:t>
-            </a:r>
-            <a:br>
+            </a:br>
+            <a:r>
               <a:rPr lang="fr-FR" sz="1800" noProof="0" dirty="0"/>
-            </a:br>
+              <a:t>- </a:t>
+            </a:r>
+            <a:r>
+              <a:rPr lang="fr-FR" sz="1800" b="1" noProof="0" dirty="0" err="1"/>
+              <a:t>has_spam_keywords</a:t>
+            </a:r>
             <a:br>
               <a:rPr lang="fr-FR" sz="1800" noProof="0" dirty="0"/>
             </a:br>
             <a:r>
               <a:rPr lang="fr-FR" sz="1800" noProof="0" dirty="0"/>
-              <a:t> - </a:t>
-            </a:r>
-            <a:r>
-              <a:rPr lang="fr-FR" sz="1800" noProof="0" dirty="0" err="1"/>
-              <a:t>has_spam_keywords</a:t>
-            </a:r>
-            <a:r>
+              <a:t>- </a:t>
+            </a:r>
+            <a:r>
+              <a:rPr lang="fr-FR" sz="1800" b="1" noProof="0" dirty="0" err="1"/>
+              <a:t>char_count</a:t>
+            </a:r>
+            <a:br>
               <a:rPr lang="fr-FR" sz="1800" noProof="0" dirty="0"/>
-              <a:t>: une variable binaire (0 ou 1) </a:t>
-            </a:r>
-            <a:r>
-              <a:rPr lang="fr-FR" sz="1800" noProof="0" dirty="0" err="1"/>
-              <a:t>indicant</a:t>
-            </a:r>
+            </a:br>
             <a:r>
               <a:rPr lang="fr-FR" sz="1800" noProof="0" dirty="0"/>
-              <a:t> si le message contient le mot clé ou non</a:t>
-            </a:r>
-            <a:br>
+              <a:t>- </a:t>
+            </a:r>
+            <a:r>
+              <a:rPr lang="fr-FR" sz="1800" b="1" noProof="0" dirty="0" err="1"/>
+              <a:t>exclamation_count</a:t>
+            </a:r>
+            <a:br>
+              <a:rPr lang="fr-FR" sz="1800" dirty="0"/>
+            </a:br>
+            <a:r>
               <a:rPr lang="fr-FR" sz="1800" noProof="0" dirty="0"/>
-            </a:br>
+              <a:t>- </a:t>
+            </a:r>
+            <a:r>
+              <a:rPr lang="fr-FR" sz="1800" b="1" noProof="0" dirty="0" err="1"/>
+              <a:t>capital_ratio</a:t>
+            </a:r>
+            <a:br>
+              <a:rPr lang="fr-FR" sz="1800" noProof="0" dirty="0"/>
+            </a:br>
+            <a:r>
+              <a:rPr lang="fr-FR" sz="1800" noProof="0" dirty="0"/>
+              <a:t>- </a:t>
+            </a:r>
+            <a:r>
+              <a:rPr lang="fr-FR" sz="1800" b="1" noProof="0" dirty="0" err="1"/>
+              <a:t>has_numbers</a:t>
+            </a:r>
+            <a:br>
+              <a:rPr lang="fr-FR" sz="1800" noProof="0" dirty="0"/>
+            </a:br>
+            <a:r>
+              <a:rPr lang="fr-FR" sz="1800" noProof="0" dirty="0"/>
+              <a:t>- </a:t>
+            </a:r>
+            <a:r>
+              <a:rPr lang="fr-FR" sz="1800" b="1" noProof="0" dirty="0" err="1"/>
+              <a:t>has_currency</a:t>
+            </a:r>
+            <a:br>
+              <a:rPr lang="fr-FR" sz="1800" noProof="0" dirty="0"/>
+            </a:br>
+            <a:r>
+              <a:rPr lang="fr-FR" sz="1800" noProof="0" dirty="0"/>
+              <a:t>- </a:t>
+            </a:r>
+            <a:r>
+              <a:rPr lang="fr-FR" sz="1800" b="1" noProof="0" dirty="0" err="1"/>
+              <a:t>has_url</a:t>
+            </a:r>
+            <a:br>
+              <a:rPr lang="fr-FR" sz="1800" noProof="0" dirty="0"/>
+            </a:br>
+            <a:r>
+              <a:rPr lang="fr-FR" sz="1800" noProof="0" dirty="0"/>
+              <a:t>- </a:t>
+            </a:r>
+            <a:r>
+              <a:rPr lang="fr-FR" sz="1800" b="1" noProof="0" dirty="0" err="1"/>
+              <a:t>has_phone</a:t>
+            </a:r>
             <a:br>
               <a:rPr lang="fr-FR" sz="1800" noProof="0" dirty="0"/>
             </a:br>
@@ -13106,7 +11232,7 @@
 </p:sld>
 </file>
 
-<file path=ppt/slides/slide8.xml><?xml version="1.0" encoding="utf-8"?>
+<file path=ppt/slides/slide7.xml><?xml version="1.0" encoding="utf-8"?>
 <p:sld xmlns:a="http://schemas.openxmlformats.org/drawingml/2006/main" xmlns:r="http://schemas.openxmlformats.org/officeDocument/2006/relationships" xmlns:p="http://schemas.openxmlformats.org/presentationml/2006/main">
   <p:cSld>
     <p:spTree>
@@ -13370,15 +11496,7 @@
             </a:r>
             <a:r>
               <a:rPr lang="fr-FR" sz="1800" noProof="0" dirty="0"/>
-              <a:t> connu pour son </a:t>
-            </a:r>
-            <a:r>
-              <a:rPr lang="fr-FR" sz="1800" noProof="0" dirty="0" err="1"/>
-              <a:t>équlibre</a:t>
-            </a:r>
-            <a:r>
-              <a:rPr lang="fr-FR" sz="1800" noProof="0" dirty="0"/>
-              <a:t> entre la Vitesse et la performance.</a:t>
+              <a:t> connu pour son équilibre entre la Vitesse et la performance.</a:t>
             </a:r>
             <a:br>
               <a:rPr lang="fr-FR" sz="1800" noProof="0" dirty="0"/>
@@ -13454,7 +11572,7 @@
 </p:sld>
 </file>
 
-<file path=ppt/slides/slide9.xml><?xml version="1.0" encoding="utf-8"?>
+<file path=ppt/slides/slide8.xml><?xml version="1.0" encoding="utf-8"?>
 <p:sld xmlns:a="http://schemas.openxmlformats.org/drawingml/2006/main" xmlns:r="http://schemas.openxmlformats.org/officeDocument/2006/relationships" xmlns:p="http://schemas.openxmlformats.org/presentationml/2006/main">
   <p:cSld>
     <p:spTree>
@@ -13462,7 +11580,7 @@
         <p:cNvPr id="1" name="Shape 80">
           <a:extLst>
             <a:ext uri="{FF2B5EF4-FFF2-40B4-BE49-F238E27FC236}">
-              <a16:creationId xmlns:a16="http://schemas.microsoft.com/office/drawing/2014/main" id="{8F107260-E9E3-F2FF-2773-9B1ED7275C4E}"/>
+              <a16:creationId xmlns:a16="http://schemas.microsoft.com/office/drawing/2014/main" id="{D9DE7D89-C1F7-A4A3-4CED-1BDCD203B867}"/>
             </a:ext>
           </a:extLst>
         </p:cNvPr>
@@ -13482,7 +11600,7 @@
           <p:cNvPr id="81" name="Google Shape;81;p16">
             <a:extLst>
               <a:ext uri="{FF2B5EF4-FFF2-40B4-BE49-F238E27FC236}">
-                <a16:creationId xmlns:a16="http://schemas.microsoft.com/office/drawing/2014/main" id="{04979A22-C8E0-FFFA-9852-DCCD10627B77}"/>
+                <a16:creationId xmlns:a16="http://schemas.microsoft.com/office/drawing/2014/main" id="{C8806206-5BF8-B5CB-7F02-C901346802F4}"/>
               </a:ext>
             </a:extLst>
           </p:cNvPr>
@@ -13544,7 +11662,7 @@
           <p:cNvPr id="82" name="Google Shape;82;p16">
             <a:extLst>
               <a:ext uri="{FF2B5EF4-FFF2-40B4-BE49-F238E27FC236}">
-                <a16:creationId xmlns:a16="http://schemas.microsoft.com/office/drawing/2014/main" id="{2AECFF55-D3E0-E752-1051-22457DE80FFD}"/>
+                <a16:creationId xmlns:a16="http://schemas.microsoft.com/office/drawing/2014/main" id="{A76B9C11-15D3-4C6F-276A-F0FAA446B3B5}"/>
               </a:ext>
             </a:extLst>
           </p:cNvPr>
@@ -13575,24 +11693,24 @@
           <a:lstStyle/>
           <a:p>
             <a:r>
-              <a:rPr lang="fr-FR" b="1" dirty="0"/>
+              <a:rPr lang="fr-FR" b="1" noProof="0" dirty="0"/>
               <a:t>Architecture des modèles neuronaux </a:t>
             </a:r>
             <a:br>
-              <a:rPr lang="fr-FR" b="1" dirty="0"/>
-            </a:br>
-            <a:br>
-              <a:rPr lang="fr-FR" dirty="0"/>
-            </a:br>
-            <a:r>
-              <a:rPr lang="fr-FR" sz="2000" dirty="0"/>
+              <a:rPr lang="fr-FR" b="1" noProof="0" dirty="0"/>
+            </a:br>
+            <a:br>
+              <a:rPr lang="fr-FR" noProof="0" dirty="0"/>
+            </a:br>
+            <a:r>
+              <a:rPr lang="fr-FR" sz="2000" noProof="0" dirty="0"/>
               <a:t>- 2 réseaux neuronaux à propagation directe pour une classification binaire efficace</a:t>
             </a:r>
             <a:br>
-              <a:rPr lang="fr-FR" b="1" dirty="0"/>
-            </a:br>
-            <a:br>
-              <a:rPr lang="fr" sz="2400" dirty="0">
+              <a:rPr lang="fr-FR" b="1" noProof="0" dirty="0"/>
+            </a:br>
+            <a:br>
+              <a:rPr lang="fr-FR" sz="2400" noProof="0" dirty="0">
                 <a:solidFill>
                   <a:srgbClr val="015955"/>
                 </a:solidFill>
@@ -13603,7 +11721,7 @@
               </a:rPr>
             </a:br>
             <a:br>
-              <a:rPr lang="fr" sz="2400" dirty="0">
+              <a:rPr lang="fr-FR" sz="2400" noProof="0" dirty="0">
                 <a:solidFill>
                   <a:srgbClr val="015955"/>
                 </a:solidFill>
@@ -13613,7 +11731,7 @@
                 <a:sym typeface="Inter"/>
               </a:rPr>
             </a:br>
-            <a:endParaRPr sz="2400" dirty="0">
+            <a:endParaRPr lang="fr-FR" sz="2400" noProof="0" dirty="0">
               <a:solidFill>
                 <a:srgbClr val="015955"/>
               </a:solidFill>
@@ -13630,7 +11748,7 @@
           <p:cNvPr id="83" name="Google Shape;83;p16">
             <a:extLst>
               <a:ext uri="{FF2B5EF4-FFF2-40B4-BE49-F238E27FC236}">
-                <a16:creationId xmlns:a16="http://schemas.microsoft.com/office/drawing/2014/main" id="{8C51FDFF-64D4-7826-EACF-38E4037EB7A9}"/>
+                <a16:creationId xmlns:a16="http://schemas.microsoft.com/office/drawing/2014/main" id="{1672457B-229E-7F7A-C9FF-AD2C3D6ABAA0}"/>
               </a:ext>
             </a:extLst>
           </p:cNvPr>
@@ -13663,7 +11781,7 @@
           <p:cNvPr id="84" name="Google Shape;84;p16">
             <a:extLst>
               <a:ext uri="{FF2B5EF4-FFF2-40B4-BE49-F238E27FC236}">
-                <a16:creationId xmlns:a16="http://schemas.microsoft.com/office/drawing/2014/main" id="{F5F910D5-3B49-70D5-2E53-E96797673320}"/>
+                <a16:creationId xmlns:a16="http://schemas.microsoft.com/office/drawing/2014/main" id="{2BE524D9-0AA5-9467-7381-4ECE57E3DE0D}"/>
               </a:ext>
             </a:extLst>
           </p:cNvPr>
@@ -13676,8 +11794,8 @@
         </p:nvSpPr>
         <p:spPr>
           <a:xfrm>
-            <a:off x="3526124" y="341931"/>
-            <a:ext cx="5455142" cy="4441788"/>
+            <a:off x="3588119" y="579248"/>
+            <a:ext cx="5315100" cy="4162117"/>
           </a:xfrm>
           <a:prstGeom prst="rect">
             <a:avLst/>
@@ -13694,124 +11812,155 @@
           <a:lstStyle/>
           <a:p>
             <a:r>
-              <a:rPr lang="fr-FR" sz="1600" b="1" noProof="0" dirty="0"/>
-              <a:t>Conception:</a:t>
-            </a:r>
-            <a:br>
-              <a:rPr lang="fr-FR" sz="1600" noProof="0" dirty="0"/>
-            </a:br>
-            <a:br>
-              <a:rPr lang="fr-FR" sz="1600" noProof="0" dirty="0"/>
-            </a:br>
-            <a:r>
-              <a:rPr lang="fr-FR" sz="1600" b="1" noProof="0" dirty="0"/>
-              <a:t>Couche d’entrée</a:t>
-            </a:r>
-            <a:r>
-              <a:rPr lang="fr-FR" sz="1600" noProof="0" dirty="0"/>
-              <a:t>: 392 variables (384 de Sentence Transformers + 8 variables spécifiques).</a:t>
-            </a:r>
-            <a:br>
-              <a:rPr lang="fr-FR" sz="1600" noProof="0" dirty="0"/>
-            </a:br>
-            <a:br>
-              <a:rPr lang="fr-FR" sz="1600" noProof="0" dirty="0"/>
-            </a:br>
-            <a:r>
-              <a:rPr lang="fr-FR" sz="1600" b="1" noProof="0" dirty="0"/>
-              <a:t>Couche de sortie</a:t>
-            </a:r>
-            <a:r>
-              <a:rPr lang="fr-FR" sz="1600" noProof="0" dirty="0"/>
-              <a:t>: Simple neurone avec l’activation sigmoïde pour la classification binaire (spam/</a:t>
-            </a:r>
-            <a:r>
-              <a:rPr lang="fr-FR" sz="1600" noProof="0" dirty="0" err="1"/>
-              <a:t>ham</a:t>
-            </a:r>
-            <a:r>
-              <a:rPr lang="fr-FR" sz="1600" noProof="0" dirty="0"/>
-              <a:t>).</a:t>
-            </a:r>
-            <a:br>
-              <a:rPr lang="fr-FR" sz="1600" noProof="0" dirty="0"/>
-            </a:br>
-            <a:br>
-              <a:rPr lang="fr-FR" sz="1600" noProof="0" dirty="0"/>
-            </a:br>
-            <a:r>
-              <a:rPr lang="fr-FR" sz="1600" b="1" noProof="0" dirty="0"/>
-              <a:t>Activation</a:t>
-            </a:r>
-            <a:r>
-              <a:rPr lang="fr-FR" sz="1600" noProof="0" dirty="0"/>
-              <a:t>: </a:t>
-            </a:r>
-            <a:r>
-              <a:rPr lang="fr-FR" sz="1600" noProof="0" dirty="0" err="1"/>
+              <a:rPr lang="fr-FR" sz="1400" b="1" noProof="0" dirty="0" err="1"/>
+              <a:t>SimpleSpamDetector</a:t>
+            </a:r>
+            <a:r>
+              <a:rPr lang="fr-FR" sz="1400" b="1" noProof="0" dirty="0"/>
+              <a:t>:</a:t>
+            </a:r>
+            <a:br>
+              <a:rPr lang="fr-FR" sz="1400" noProof="0" dirty="0"/>
+            </a:br>
+            <a:br>
+              <a:rPr lang="fr-FR" sz="1400" noProof="0" dirty="0"/>
+            </a:br>
+            <a:r>
+              <a:rPr lang="fr-FR" sz="1400" noProof="0" dirty="0"/>
+              <a:t>Architecture: Couche d’entrée </a:t>
+            </a:r>
+            <a:r>
+              <a:rPr lang="fr-FR" sz="1400" b="1" noProof="0" dirty="0"/>
+              <a:t>(392 variables</a:t>
+            </a:r>
+            <a:r>
+              <a:rPr lang="fr-FR" sz="1400" noProof="0" dirty="0"/>
+              <a:t>) → Couche cachée (</a:t>
+            </a:r>
+            <a:r>
+              <a:rPr lang="fr-FR" sz="1400" b="1" noProof="0" dirty="0"/>
+              <a:t>128 neurones</a:t>
+            </a:r>
+            <a:r>
+              <a:rPr lang="fr-FR" sz="1400" noProof="0" dirty="0"/>
+              <a:t>, activation </a:t>
+            </a:r>
+            <a:r>
+              <a:rPr lang="fr-FR" sz="1400" noProof="0" dirty="0" err="1"/>
               <a:t>ReLU</a:t>
             </a:r>
             <a:r>
-              <a:rPr lang="fr-FR" sz="1600" noProof="0" dirty="0"/>
-              <a:t> pour la non-linéarité dans les couches cachées.</a:t>
-            </a:r>
-            <a:br>
-              <a:rPr lang="fr-FR" sz="1600" noProof="0" dirty="0"/>
-            </a:br>
-            <a:br>
-              <a:rPr lang="fr-FR" sz="1600" noProof="0" dirty="0"/>
-            </a:br>
-            <a:r>
-              <a:rPr lang="fr-FR" sz="1600" b="1" noProof="0" dirty="0"/>
-              <a:t>Dropout</a:t>
-            </a:r>
-            <a:r>
-              <a:rPr lang="fr-FR" sz="1600" noProof="0" dirty="0"/>
-              <a:t>: Inclut pour prévenir l’</a:t>
-            </a:r>
-            <a:r>
-              <a:rPr lang="fr-FR" sz="1600" noProof="0" dirty="0" err="1"/>
-              <a:t>overfitting</a:t>
-            </a:r>
-            <a:r>
-              <a:rPr lang="fr-FR" sz="1600" noProof="0" dirty="0"/>
-              <a:t>, </a:t>
-            </a:r>
-            <a:r>
-              <a:rPr lang="fr-FR" sz="1600" noProof="0" dirty="0" err="1"/>
-              <a:t>surout</a:t>
-            </a:r>
-            <a:r>
-              <a:rPr lang="fr-FR" sz="1600" noProof="0" dirty="0"/>
-              <a:t> dans un </a:t>
-            </a:r>
-            <a:r>
-              <a:rPr lang="fr-FR" sz="1600" noProof="0" dirty="0" err="1"/>
-              <a:t>context</a:t>
-            </a:r>
-            <a:r>
-              <a:rPr lang="fr-FR" sz="1600" noProof="0" dirty="0"/>
-              <a:t> du jeu de données restreint</a:t>
-            </a:r>
-            <a:br>
-              <a:rPr lang="fr-FR" sz="1600" noProof="0" dirty="0"/>
-            </a:br>
-            <a:br>
-              <a:rPr lang="fr-FR" sz="1600" noProof="0" dirty="0"/>
-            </a:br>
-            <a:r>
-              <a:rPr lang="fr-FR" sz="1600" b="1" noProof="0" dirty="0"/>
-              <a:t>Efficacité</a:t>
-            </a:r>
-            <a:r>
-              <a:rPr lang="fr-FR" sz="1600" noProof="0" dirty="0"/>
-              <a:t>: les deux modèles priorisent l’architecture à propagation directe pour équilibrer la performance avec les ressources de calcul pour assurer un déploiement rapide.</a:t>
-            </a:r>
-            <a:br>
-              <a:rPr lang="fr-FR" noProof="0" dirty="0"/>
-            </a:br>
-            <a:br>
-              <a:rPr lang="fr-FR" noProof="0" dirty="0"/>
+              <a:rPr lang="fr-FR" sz="1400" noProof="0" dirty="0"/>
+              <a:t>, Dropout) → Couche de sortie (</a:t>
+            </a:r>
+            <a:r>
+              <a:rPr lang="fr-FR" sz="1400" b="1" noProof="0" dirty="0"/>
+              <a:t>1 neurone</a:t>
+            </a:r>
+            <a:r>
+              <a:rPr lang="fr-FR" sz="1400" noProof="0" dirty="0"/>
+              <a:t>, activation </a:t>
+            </a:r>
+            <a:r>
+              <a:rPr lang="fr-FR" sz="1400" noProof="0" dirty="0" err="1"/>
+              <a:t>Sigmoid</a:t>
+            </a:r>
+            <a:r>
+              <a:rPr lang="fr-FR" sz="1400" noProof="0" dirty="0"/>
+              <a:t> pour la probabilité).</a:t>
+            </a:r>
+            <a:br>
+              <a:rPr lang="fr-FR" sz="1400" noProof="0" dirty="0"/>
+            </a:br>
+            <a:br>
+              <a:rPr lang="fr-FR" sz="1400" noProof="0" dirty="0"/>
+            </a:br>
+            <a:r>
+              <a:rPr lang="fr-FR" sz="1400" b="1" noProof="0" dirty="0"/>
+              <a:t>Paramètres: environ 50,433.</a:t>
+            </a:r>
+            <a:br>
+              <a:rPr lang="fr-FR" sz="1400" noProof="0" dirty="0"/>
+            </a:br>
+            <a:br>
+              <a:rPr lang="fr-FR" sz="1400" noProof="0" dirty="0"/>
+            </a:br>
+            <a:br>
+              <a:rPr lang="fr-FR" sz="1400" noProof="0" dirty="0"/>
+            </a:br>
+            <a:r>
+              <a:rPr lang="fr-FR" sz="1400" b="1" noProof="0" dirty="0" err="1"/>
+              <a:t>UltraSimpleSpamDetector</a:t>
+            </a:r>
+            <a:r>
+              <a:rPr lang="fr-FR" sz="1400" b="1" noProof="0" dirty="0"/>
+              <a:t>:</a:t>
+            </a:r>
+            <a:br>
+              <a:rPr lang="fr-FR" sz="1400" noProof="0" dirty="0"/>
+            </a:br>
+            <a:br>
+              <a:rPr lang="fr-FR" sz="1400" noProof="0" dirty="0"/>
+            </a:br>
+            <a:r>
+              <a:rPr lang="fr-FR" sz="1400" noProof="0" dirty="0"/>
+              <a:t>Architecture: Couche d’entrée (</a:t>
+            </a:r>
+            <a:r>
+              <a:rPr lang="fr-FR" sz="1400" b="1" noProof="0" dirty="0"/>
+              <a:t>392 variables</a:t>
+            </a:r>
+            <a:r>
+              <a:rPr lang="fr-FR" sz="1400" noProof="0" dirty="0"/>
+              <a:t>) → Couche cachée (</a:t>
+            </a:r>
+            <a:r>
+              <a:rPr lang="fr-FR" sz="1400" b="1" noProof="0" dirty="0"/>
+              <a:t>64 neurones</a:t>
+            </a:r>
+            <a:r>
+              <a:rPr lang="fr-FR" sz="1400" noProof="0" dirty="0"/>
+              <a:t>, activation </a:t>
+            </a:r>
+            <a:r>
+              <a:rPr lang="fr-FR" sz="1400" noProof="0" dirty="0" err="1"/>
+              <a:t>ReLU</a:t>
+            </a:r>
+            <a:r>
+              <a:rPr lang="fr-FR" sz="1400" noProof="0" dirty="0"/>
+              <a:t>, Dropout) → Couche de sortie (</a:t>
+            </a:r>
+            <a:r>
+              <a:rPr lang="fr-FR" sz="1400" b="1" noProof="0" dirty="0"/>
+              <a:t>1 neurone</a:t>
+            </a:r>
+            <a:r>
+              <a:rPr lang="fr-FR" sz="1400" noProof="0" dirty="0"/>
+              <a:t>, activation </a:t>
+            </a:r>
+            <a:r>
+              <a:rPr lang="fr-FR" sz="1400" noProof="0" dirty="0" err="1"/>
+              <a:t>Sigmoid</a:t>
+            </a:r>
+            <a:r>
+              <a:rPr lang="fr-FR" sz="1400" noProof="0" dirty="0"/>
+              <a:t> pour la probabilité).</a:t>
+            </a:r>
+            <a:br>
+              <a:rPr lang="fr-FR" sz="1400" noProof="0" dirty="0"/>
+            </a:br>
+            <a:br>
+              <a:rPr lang="fr-FR" sz="1400" noProof="0" dirty="0"/>
+            </a:br>
+            <a:r>
+              <a:rPr lang="fr-FR" sz="1400" b="1" noProof="0" dirty="0"/>
+              <a:t>Paramètres: environ 25,217.</a:t>
+            </a:r>
+            <a:br>
+              <a:rPr lang="fr-FR" sz="1400" noProof="0" dirty="0"/>
+            </a:br>
+            <a:br>
+              <a:rPr lang="fr-FR" sz="1400" noProof="0" dirty="0"/>
             </a:br>
             <a:br>
               <a:rPr lang="fr-FR" noProof="0" dirty="0"/>
@@ -13835,7 +11984,764 @@
     </p:spTree>
     <p:extLst>
       <p:ext uri="{BB962C8B-B14F-4D97-AF65-F5344CB8AC3E}">
-        <p14:creationId xmlns:p14="http://schemas.microsoft.com/office/powerpoint/2010/main" val="2564139638"/>
+        <p14:creationId xmlns:p14="http://schemas.microsoft.com/office/powerpoint/2010/main" val="851915911"/>
+      </p:ext>
+    </p:extLst>
+  </p:cSld>
+  <p:clrMapOvr>
+    <a:masterClrMapping/>
+  </p:clrMapOvr>
+</p:sld>
+</file>
+
+<file path=ppt/slides/slide9.xml><?xml version="1.0" encoding="utf-8"?>
+<p:sld xmlns:a="http://schemas.openxmlformats.org/drawingml/2006/main" xmlns:r="http://schemas.openxmlformats.org/officeDocument/2006/relationships" xmlns:p="http://schemas.openxmlformats.org/presentationml/2006/main">
+  <p:cSld>
+    <p:spTree>
+      <p:nvGrpSpPr>
+        <p:cNvPr id="1" name="Shape 80">
+          <a:extLst>
+            <a:ext uri="{FF2B5EF4-FFF2-40B4-BE49-F238E27FC236}">
+              <a16:creationId xmlns:a16="http://schemas.microsoft.com/office/drawing/2014/main" id="{ED642B1F-86B2-60A5-451B-100199CED629}"/>
+            </a:ext>
+          </a:extLst>
+        </p:cNvPr>
+        <p:cNvGrpSpPr/>
+        <p:nvPr/>
+      </p:nvGrpSpPr>
+      <p:grpSpPr>
+        <a:xfrm>
+          <a:off x="0" y="0"/>
+          <a:ext cx="0" cy="0"/>
+          <a:chOff x="0" y="0"/>
+          <a:chExt cx="0" cy="0"/>
+        </a:xfrm>
+      </p:grpSpPr>
+      <p:sp>
+        <p:nvSpPr>
+          <p:cNvPr id="81" name="Google Shape;81;p16">
+            <a:extLst>
+              <a:ext uri="{FF2B5EF4-FFF2-40B4-BE49-F238E27FC236}">
+                <a16:creationId xmlns:a16="http://schemas.microsoft.com/office/drawing/2014/main" id="{66300018-435D-F945-6779-2C2631A5C23F}"/>
+              </a:ext>
+            </a:extLst>
+          </p:cNvPr>
+          <p:cNvSpPr/>
+          <p:nvPr/>
+        </p:nvSpPr>
+        <p:spPr>
+          <a:xfrm>
+            <a:off x="5499" y="-17775"/>
+            <a:ext cx="3520625" cy="5161200"/>
+          </a:xfrm>
+          <a:prstGeom prst="rect">
+            <a:avLst/>
+          </a:prstGeom>
+          <a:solidFill>
+            <a:srgbClr val="C3FFFC"/>
+          </a:solidFill>
+          <a:ln>
+            <a:noFill/>
+          </a:ln>
+        </p:spPr>
+        <p:txBody>
+          <a:bodyPr spcFirstLastPara="1" wrap="square" lIns="91425" tIns="91425" rIns="91425" bIns="91425" anchor="ctr" anchorCtr="0">
+            <a:noAutofit/>
+          </a:bodyPr>
+          <a:lstStyle/>
+          <a:p>
+            <a:pPr marL="0" marR="0" lvl="0" indent="0" algn="l" rtl="0">
+              <a:lnSpc>
+                <a:spcPct val="100000"/>
+              </a:lnSpc>
+              <a:spcBef>
+                <a:spcPts val="0"/>
+              </a:spcBef>
+              <a:spcAft>
+                <a:spcPts val="0"/>
+              </a:spcAft>
+              <a:buClr>
+                <a:srgbClr val="000000"/>
+              </a:buClr>
+              <a:buSzPts val="1400"/>
+              <a:buFont typeface="Arial"/>
+              <a:buNone/>
+            </a:pPr>
+            <a:endParaRPr sz="1400" b="0" i="0" u="none" strike="noStrike" cap="none">
+              <a:solidFill>
+                <a:srgbClr val="000000"/>
+              </a:solidFill>
+              <a:latin typeface="Arial"/>
+              <a:ea typeface="Arial"/>
+              <a:cs typeface="Arial"/>
+              <a:sym typeface="Arial"/>
+            </a:endParaRPr>
+          </a:p>
+        </p:txBody>
+      </p:sp>
+      <p:sp>
+        <p:nvSpPr>
+          <p:cNvPr id="82" name="Google Shape;82;p16">
+            <a:extLst>
+              <a:ext uri="{FF2B5EF4-FFF2-40B4-BE49-F238E27FC236}">
+                <a16:creationId xmlns:a16="http://schemas.microsoft.com/office/drawing/2014/main" id="{D4136558-C25D-9E12-F881-F17613D060B8}"/>
+              </a:ext>
+            </a:extLst>
+          </p:cNvPr>
+          <p:cNvSpPr txBox="1">
+            <a:spLocks noGrp="1"/>
+          </p:cNvSpPr>
+          <p:nvPr>
+            <p:ph type="title"/>
+          </p:nvPr>
+        </p:nvSpPr>
+        <p:spPr>
+          <a:xfrm>
+            <a:off x="291027" y="1511458"/>
+            <a:ext cx="2988031" cy="1857766"/>
+          </a:xfrm>
+          <a:prstGeom prst="rect">
+            <a:avLst/>
+          </a:prstGeom>
+          <a:noFill/>
+          <a:ln>
+            <a:noFill/>
+          </a:ln>
+        </p:spPr>
+        <p:txBody>
+          <a:bodyPr spcFirstLastPara="1" wrap="square" lIns="91425" tIns="91425" rIns="91425" bIns="91425" anchor="t" anchorCtr="0">
+            <a:noAutofit/>
+          </a:bodyPr>
+          <a:lstStyle/>
+          <a:p>
+            <a:r>
+              <a:rPr lang="fr-FR" b="1" dirty="0"/>
+              <a:t>Evaluation et comparaison des modèles</a:t>
+            </a:r>
+            <a:br>
+              <a:rPr lang="fr-FR" dirty="0"/>
+            </a:br>
+            <a:br>
+              <a:rPr lang="en-US" dirty="0"/>
+            </a:br>
+            <a:br>
+              <a:rPr lang="fr-FR" dirty="0"/>
+            </a:br>
+            <a:br>
+              <a:rPr lang="en-US" dirty="0"/>
+            </a:br>
+            <a:br>
+              <a:rPr lang="fr-FR" dirty="0"/>
+            </a:br>
+            <a:br>
+              <a:rPr lang="fr-FR" b="1" dirty="0"/>
+            </a:br>
+            <a:br>
+              <a:rPr lang="fr" sz="2400" dirty="0">
+                <a:solidFill>
+                  <a:srgbClr val="015955"/>
+                </a:solidFill>
+                <a:latin typeface="Inter"/>
+                <a:ea typeface="Inter"/>
+                <a:cs typeface="Inter"/>
+                <a:sym typeface="Inter"/>
+              </a:rPr>
+            </a:br>
+            <a:br>
+              <a:rPr lang="fr" sz="2400" dirty="0">
+                <a:solidFill>
+                  <a:srgbClr val="015955"/>
+                </a:solidFill>
+                <a:latin typeface="Inter"/>
+                <a:ea typeface="Inter"/>
+                <a:cs typeface="Inter"/>
+                <a:sym typeface="Inter"/>
+              </a:rPr>
+            </a:br>
+            <a:endParaRPr sz="2400" dirty="0">
+              <a:solidFill>
+                <a:srgbClr val="015955"/>
+              </a:solidFill>
+              <a:latin typeface="Inter"/>
+              <a:ea typeface="Inter"/>
+              <a:cs typeface="Inter"/>
+              <a:sym typeface="Inter"/>
+            </a:endParaRPr>
+          </a:p>
+        </p:txBody>
+      </p:sp>
+      <p:pic>
+        <p:nvPicPr>
+          <p:cNvPr id="83" name="Google Shape;83;p16">
+            <a:extLst>
+              <a:ext uri="{FF2B5EF4-FFF2-40B4-BE49-F238E27FC236}">
+                <a16:creationId xmlns:a16="http://schemas.microsoft.com/office/drawing/2014/main" id="{043A57F9-4A1F-D430-FEA6-30310DBE76BE}"/>
+              </a:ext>
+            </a:extLst>
+          </p:cNvPr>
+          <p:cNvPicPr preferRelativeResize="0"/>
+          <p:nvPr/>
+        </p:nvPicPr>
+        <p:blipFill rotWithShape="1">
+          <a:blip r:embed="rId3">
+            <a:alphaModFix/>
+          </a:blip>
+          <a:srcRect/>
+          <a:stretch/>
+        </p:blipFill>
+        <p:spPr>
+          <a:xfrm>
+            <a:off x="463375" y="482852"/>
+            <a:ext cx="576900" cy="385904"/>
+          </a:xfrm>
+          <a:prstGeom prst="rect">
+            <a:avLst/>
+          </a:prstGeom>
+          <a:noFill/>
+          <a:ln>
+            <a:noFill/>
+          </a:ln>
+        </p:spPr>
+      </p:pic>
+      <p:sp>
+        <p:nvSpPr>
+          <p:cNvPr id="84" name="Google Shape;84;p16">
+            <a:extLst>
+              <a:ext uri="{FF2B5EF4-FFF2-40B4-BE49-F238E27FC236}">
+                <a16:creationId xmlns:a16="http://schemas.microsoft.com/office/drawing/2014/main" id="{184E04A7-6DCB-FAF8-0D66-F4C55D80D0DE}"/>
+              </a:ext>
+            </a:extLst>
+          </p:cNvPr>
+          <p:cNvSpPr txBox="1">
+            <a:spLocks noGrp="1"/>
+          </p:cNvSpPr>
+          <p:nvPr>
+            <p:ph type="ctrTitle" idx="4294967295"/>
+          </p:nvPr>
+        </p:nvSpPr>
+        <p:spPr>
+          <a:xfrm>
+            <a:off x="3564586" y="482852"/>
+            <a:ext cx="5455142" cy="4488698"/>
+          </a:xfrm>
+          <a:prstGeom prst="rect">
+            <a:avLst/>
+          </a:prstGeom>
+          <a:noFill/>
+          <a:ln>
+            <a:noFill/>
+          </a:ln>
+        </p:spPr>
+        <p:txBody>
+          <a:bodyPr spcFirstLastPara="1" wrap="square" lIns="91425" tIns="91425" rIns="91425" bIns="91425" anchor="t" anchorCtr="0">
+            <a:noAutofit/>
+          </a:bodyPr>
+          <a:lstStyle/>
+          <a:p>
+            <a:r>
+              <a:rPr lang="fr-FR" sz="1400" b="1" noProof="0" dirty="0" err="1"/>
+              <a:t>Ultra-Simple</a:t>
+            </a:r>
+            <a:r>
+              <a:rPr lang="fr-FR" sz="1400" b="1" noProof="0" dirty="0"/>
+              <a:t> NN</a:t>
+            </a:r>
+            <a:br>
+              <a:rPr lang="fr-FR" sz="1400" b="1" noProof="0" dirty="0"/>
+            </a:br>
+            <a:br>
+              <a:rPr lang="fr-FR" sz="1400" b="1" noProof="0" dirty="0"/>
+            </a:br>
+            <a:r>
+              <a:rPr lang="fr-FR" sz="1400" noProof="0" dirty="0"/>
+              <a:t>Sachant que les deux modèles sont efficaces, il vaut mieux choisir le modèle plus simple: </a:t>
+            </a:r>
+            <a:r>
+              <a:rPr lang="fr-FR" sz="1400" b="1" noProof="0" dirty="0" err="1"/>
+              <a:t>Ultra-Simple</a:t>
+            </a:r>
+            <a:r>
+              <a:rPr lang="fr-FR" sz="1400" b="1" noProof="0" dirty="0"/>
+              <a:t> Neural Network </a:t>
+            </a:r>
+            <a:r>
+              <a:rPr lang="fr-FR" sz="1400" noProof="0" dirty="0"/>
+              <a:t>car il compte deux fois moins de paramètres tout en obtenant les résultats comparables ce qui allège les ressources de calcul pour la détection des spams.</a:t>
+            </a:r>
+            <a:br>
+              <a:rPr lang="fr-FR" sz="1400" noProof="0" dirty="0"/>
+            </a:br>
+            <a:br>
+              <a:rPr lang="fr-FR" sz="1600" noProof="0" dirty="0"/>
+            </a:br>
+            <a:br>
+              <a:rPr lang="fr-FR" noProof="0" dirty="0"/>
+            </a:br>
+            <a:br>
+              <a:rPr lang="fr-FR" sz="1600" noProof="0" dirty="0"/>
+            </a:br>
+            <a:br>
+              <a:rPr lang="fr-FR" noProof="0" dirty="0"/>
+            </a:br>
+            <a:endParaRPr lang="fr-FR" sz="1600" noProof="0" dirty="0"/>
+          </a:p>
+        </p:txBody>
+      </p:sp>
+      <p:pic>
+        <p:nvPicPr>
+          <p:cNvPr id="3" name="Image 2" descr="Une image contenant texte, capture d’écran, diagramme, Rectangle&#10;&#10;Le contenu généré par l’IA peut être incorrect.">
+            <a:extLst>
+              <a:ext uri="{FF2B5EF4-FFF2-40B4-BE49-F238E27FC236}">
+                <a16:creationId xmlns:a16="http://schemas.microsoft.com/office/drawing/2014/main" id="{C702E82C-DF40-71D0-AE1B-AB16CE574622}"/>
+              </a:ext>
+            </a:extLst>
+          </p:cNvPr>
+          <p:cNvPicPr>
+            <a:picLocks noChangeAspect="1"/>
+          </p:cNvPicPr>
+          <p:nvPr/>
+        </p:nvPicPr>
+        <p:blipFill>
+          <a:blip r:embed="rId4"/>
+          <a:stretch>
+            <a:fillRect/>
+          </a:stretch>
+        </p:blipFill>
+        <p:spPr>
+          <a:xfrm>
+            <a:off x="3811652" y="3106446"/>
+            <a:ext cx="2049308" cy="1942716"/>
+          </a:xfrm>
+          <a:prstGeom prst="rect">
+            <a:avLst/>
+          </a:prstGeom>
+        </p:spPr>
+      </p:pic>
+      <p:pic>
+        <p:nvPicPr>
+          <p:cNvPr id="5" name="Image 4" descr="Une image contenant texte, capture d’écran, diagramme, Rectangle&#10;&#10;Le contenu généré par l’IA peut être incorrect.">
+            <a:extLst>
+              <a:ext uri="{FF2B5EF4-FFF2-40B4-BE49-F238E27FC236}">
+                <a16:creationId xmlns:a16="http://schemas.microsoft.com/office/drawing/2014/main" id="{4F46F44E-8250-E270-299C-6F5BD20E1F4E}"/>
+              </a:ext>
+            </a:extLst>
+          </p:cNvPr>
+          <p:cNvPicPr>
+            <a:picLocks noChangeAspect="1"/>
+          </p:cNvPicPr>
+          <p:nvPr/>
+        </p:nvPicPr>
+        <p:blipFill>
+          <a:blip r:embed="rId5"/>
+          <a:stretch>
+            <a:fillRect/>
+          </a:stretch>
+        </p:blipFill>
+        <p:spPr>
+          <a:xfrm>
+            <a:off x="6415690" y="2972063"/>
+            <a:ext cx="2049308" cy="1999487"/>
+          </a:xfrm>
+          <a:prstGeom prst="rect">
+            <a:avLst/>
+          </a:prstGeom>
+        </p:spPr>
+      </p:pic>
+      <p:graphicFrame>
+        <p:nvGraphicFramePr>
+          <p:cNvPr id="4" name="Tableau 3">
+            <a:extLst>
+              <a:ext uri="{FF2B5EF4-FFF2-40B4-BE49-F238E27FC236}">
+                <a16:creationId xmlns:a16="http://schemas.microsoft.com/office/drawing/2014/main" id="{D61D86C2-50C7-67FD-5286-56FFDA31AC41}"/>
+              </a:ext>
+            </a:extLst>
+          </p:cNvPr>
+          <p:cNvGraphicFramePr>
+            <a:graphicFrameLocks noGrp="1"/>
+          </p:cNvGraphicFramePr>
+          <p:nvPr>
+            <p:extLst>
+              <p:ext uri="{D42A27DB-BD31-4B8C-83A1-F6EECF244321}">
+                <p14:modId xmlns:p14="http://schemas.microsoft.com/office/powerpoint/2010/main" val="1255254537"/>
+              </p:ext>
+            </p:extLst>
+          </p:nvPr>
+        </p:nvGraphicFramePr>
+        <p:xfrm>
+          <a:off x="4253947" y="2215031"/>
+          <a:ext cx="3822700" cy="695588"/>
+        </p:xfrm>
+        <a:graphic>
+          <a:graphicData uri="http://schemas.openxmlformats.org/drawingml/2006/table">
+            <a:tbl>
+              <a:tblPr>
+                <a:tableStyleId>{5C22544A-7EE6-4342-B048-85BDC9FD1C3A}</a:tableStyleId>
+              </a:tblPr>
+              <a:tblGrid>
+                <a:gridCol w="1320800">
+                  <a:extLst>
+                    <a:ext uri="{9D8B030D-6E8A-4147-A177-3AD203B41FA5}">
+                      <a16:colId xmlns:a16="http://schemas.microsoft.com/office/drawing/2014/main" val="1580352960"/>
+                    </a:ext>
+                  </a:extLst>
+                </a:gridCol>
+                <a:gridCol w="749300">
+                  <a:extLst>
+                    <a:ext uri="{9D8B030D-6E8A-4147-A177-3AD203B41FA5}">
+                      <a16:colId xmlns:a16="http://schemas.microsoft.com/office/drawing/2014/main" val="527125773"/>
+                    </a:ext>
+                  </a:extLst>
+                </a:gridCol>
+                <a:gridCol w="863600">
+                  <a:extLst>
+                    <a:ext uri="{9D8B030D-6E8A-4147-A177-3AD203B41FA5}">
+                      <a16:colId xmlns:a16="http://schemas.microsoft.com/office/drawing/2014/main" val="2468544463"/>
+                    </a:ext>
+                  </a:extLst>
+                </a:gridCol>
+                <a:gridCol w="889000">
+                  <a:extLst>
+                    <a:ext uri="{9D8B030D-6E8A-4147-A177-3AD203B41FA5}">
+                      <a16:colId xmlns:a16="http://schemas.microsoft.com/office/drawing/2014/main" val="3235623358"/>
+                    </a:ext>
+                  </a:extLst>
+                </a:gridCol>
+              </a:tblGrid>
+              <a:tr h="225239">
+                <a:tc>
+                  <a:txBody>
+                    <a:bodyPr/>
+                    <a:lstStyle/>
+                    <a:p>
+                      <a:pPr algn="l" fontAlgn="b">
+                        <a:buNone/>
+                      </a:pPr>
+                      <a:r>
+                        <a:rPr lang="fr-FR" sz="1200" u="none" strike="noStrike" dirty="0">
+                          <a:effectLst/>
+                        </a:rPr>
+                        <a:t> </a:t>
+                      </a:r>
+                      <a:endParaRPr lang="fr-FR" sz="1200" b="0" i="0" u="none" strike="noStrike" dirty="0">
+                        <a:solidFill>
+                          <a:srgbClr val="000000"/>
+                        </a:solidFill>
+                        <a:effectLst/>
+                        <a:latin typeface="Arial" panose="020B0604020202020204" pitchFamily="34" charset="0"/>
+                      </a:endParaRPr>
+                    </a:p>
+                  </a:txBody>
+                  <a:tcPr marL="6350" marR="6350" marT="6350" marB="0" anchor="b"/>
+                </a:tc>
+                <a:tc>
+                  <a:txBody>
+                    <a:bodyPr/>
+                    <a:lstStyle/>
+                    <a:p>
+                      <a:pPr algn="l" fontAlgn="b">
+                        <a:buNone/>
+                      </a:pPr>
+                      <a:r>
+                        <a:rPr lang="fr-FR" sz="1200" b="1" u="none" strike="noStrike">
+                          <a:effectLst/>
+                        </a:rPr>
+                        <a:t>Accuracy</a:t>
+                      </a:r>
+                      <a:endParaRPr lang="fr-FR" sz="1200" b="1" i="0" u="none" strike="noStrike">
+                        <a:solidFill>
+                          <a:srgbClr val="000000"/>
+                        </a:solidFill>
+                        <a:effectLst/>
+                        <a:latin typeface="Arial" panose="020B0604020202020204" pitchFamily="34" charset="0"/>
+                      </a:endParaRPr>
+                    </a:p>
+                  </a:txBody>
+                  <a:tcPr marL="6350" marR="6350" marT="6350" marB="0" anchor="b"/>
+                </a:tc>
+                <a:tc>
+                  <a:txBody>
+                    <a:bodyPr/>
+                    <a:lstStyle/>
+                    <a:p>
+                      <a:pPr algn="l" fontAlgn="b">
+                        <a:buNone/>
+                      </a:pPr>
+                      <a:r>
+                        <a:rPr lang="fr-FR" sz="1200" b="1" u="none" strike="noStrike">
+                          <a:effectLst/>
+                        </a:rPr>
+                        <a:t>AUC Score</a:t>
+                      </a:r>
+                      <a:endParaRPr lang="fr-FR" sz="1200" b="1" i="0" u="none" strike="noStrike">
+                        <a:solidFill>
+                          <a:srgbClr val="000000"/>
+                        </a:solidFill>
+                        <a:effectLst/>
+                        <a:latin typeface="Arial" panose="020B0604020202020204" pitchFamily="34" charset="0"/>
+                      </a:endParaRPr>
+                    </a:p>
+                  </a:txBody>
+                  <a:tcPr marL="6350" marR="6350" marT="6350" marB="0" anchor="b"/>
+                </a:tc>
+                <a:tc>
+                  <a:txBody>
+                    <a:bodyPr/>
+                    <a:lstStyle/>
+                    <a:p>
+                      <a:pPr algn="l" fontAlgn="b">
+                        <a:buNone/>
+                      </a:pPr>
+                      <a:r>
+                        <a:rPr lang="fr-FR" sz="1200" b="1" u="none" strike="noStrike" dirty="0" err="1">
+                          <a:effectLst/>
+                        </a:rPr>
+                        <a:t>Parameters</a:t>
+                      </a:r>
+                      <a:endParaRPr lang="fr-FR" sz="1200" b="1" i="0" u="none" strike="noStrike" dirty="0">
+                        <a:solidFill>
+                          <a:srgbClr val="000000"/>
+                        </a:solidFill>
+                        <a:effectLst/>
+                        <a:latin typeface="Arial" panose="020B0604020202020204" pitchFamily="34" charset="0"/>
+                      </a:endParaRPr>
+                    </a:p>
+                  </a:txBody>
+                  <a:tcPr marL="6350" marR="6350" marT="6350" marB="0" anchor="b"/>
+                </a:tc>
+                <a:extLst>
+                  <a:ext uri="{0D108BD9-81ED-4DB2-BD59-A6C34878D82A}">
+                    <a16:rowId xmlns:a16="http://schemas.microsoft.com/office/drawing/2014/main" val="3967172099"/>
+                  </a:ext>
+                </a:extLst>
+              </a:tr>
+              <a:tr h="245110">
+                <a:tc>
+                  <a:txBody>
+                    <a:bodyPr/>
+                    <a:lstStyle/>
+                    <a:p>
+                      <a:pPr algn="l" fontAlgn="b">
+                        <a:buNone/>
+                      </a:pPr>
+                      <a:r>
+                        <a:rPr lang="fr-FR" sz="1200" b="1" u="none" strike="noStrike" dirty="0">
+                          <a:effectLst/>
+                        </a:rPr>
+                        <a:t>Simple NN</a:t>
+                      </a:r>
+                      <a:endParaRPr lang="fr-FR" sz="1200" b="1" i="0" u="none" strike="noStrike" dirty="0">
+                        <a:solidFill>
+                          <a:srgbClr val="000000"/>
+                        </a:solidFill>
+                        <a:effectLst/>
+                        <a:latin typeface="Arial" panose="020B0604020202020204" pitchFamily="34" charset="0"/>
+                      </a:endParaRPr>
+                    </a:p>
+                  </a:txBody>
+                  <a:tcPr marL="6350" marR="6350" marT="6350" marB="0" anchor="b"/>
+                </a:tc>
+                <a:tc>
+                  <a:txBody>
+                    <a:bodyPr/>
+                    <a:lstStyle/>
+                    <a:p>
+                      <a:pPr algn="r" fontAlgn="b">
+                        <a:buNone/>
+                      </a:pPr>
+                      <a:r>
+                        <a:rPr lang="fr-FR" sz="1200" u="none" strike="noStrike">
+                          <a:effectLst/>
+                        </a:rPr>
+                        <a:t> 0.9928</a:t>
+                      </a:r>
+                      <a:endParaRPr lang="fr-FR" sz="1200" b="0" i="0" u="none" strike="noStrike">
+                        <a:solidFill>
+                          <a:srgbClr val="000000"/>
+                        </a:solidFill>
+                        <a:effectLst/>
+                        <a:latin typeface="Arial" panose="020B0604020202020204" pitchFamily="34" charset="0"/>
+                      </a:endParaRPr>
+                    </a:p>
+                  </a:txBody>
+                  <a:tcPr marL="6350" marR="6350" marT="6350" marB="0" anchor="b"/>
+                </a:tc>
+                <a:tc>
+                  <a:txBody>
+                    <a:bodyPr/>
+                    <a:lstStyle/>
+                    <a:p>
+                      <a:pPr algn="r" fontAlgn="b">
+                        <a:buNone/>
+                      </a:pPr>
+                      <a:r>
+                        <a:rPr lang="fr-FR" sz="1200" u="none" strike="noStrike">
+                          <a:effectLst/>
+                        </a:rPr>
+                        <a:t>0.9987 </a:t>
+                      </a:r>
+                      <a:endParaRPr lang="fr-FR" sz="1200" b="0" i="0" u="none" strike="noStrike">
+                        <a:solidFill>
+                          <a:srgbClr val="000000"/>
+                        </a:solidFill>
+                        <a:effectLst/>
+                        <a:latin typeface="Arial" panose="020B0604020202020204" pitchFamily="34" charset="0"/>
+                      </a:endParaRPr>
+                    </a:p>
+                  </a:txBody>
+                  <a:tcPr marL="6350" marR="6350" marT="6350" marB="0" anchor="b"/>
+                </a:tc>
+                <a:tc>
+                  <a:txBody>
+                    <a:bodyPr/>
+                    <a:lstStyle/>
+                    <a:p>
+                      <a:pPr algn="r" fontAlgn="b">
+                        <a:buNone/>
+                      </a:pPr>
+                      <a:r>
+                        <a:rPr lang="fr-FR" sz="1200" u="none" strike="noStrike">
+                          <a:effectLst/>
+                        </a:rPr>
+                        <a:t>50,433</a:t>
+                      </a:r>
+                      <a:endParaRPr lang="fr-FR" sz="1200" b="0" i="0" u="none" strike="noStrike">
+                        <a:solidFill>
+                          <a:srgbClr val="000000"/>
+                        </a:solidFill>
+                        <a:effectLst/>
+                        <a:latin typeface="Arial" panose="020B0604020202020204" pitchFamily="34" charset="0"/>
+                      </a:endParaRPr>
+                    </a:p>
+                  </a:txBody>
+                  <a:tcPr marL="6350" marR="6350" marT="6350" marB="0" anchor="b"/>
+                </a:tc>
+                <a:extLst>
+                  <a:ext uri="{0D108BD9-81ED-4DB2-BD59-A6C34878D82A}">
+                    <a16:rowId xmlns:a16="http://schemas.microsoft.com/office/drawing/2014/main" val="2611212671"/>
+                  </a:ext>
+                </a:extLst>
+              </a:tr>
+              <a:tr h="225239">
+                <a:tc>
+                  <a:txBody>
+                    <a:bodyPr/>
+                    <a:lstStyle/>
+                    <a:p>
+                      <a:pPr algn="l" fontAlgn="b">
+                        <a:buNone/>
+                      </a:pPr>
+                      <a:r>
+                        <a:rPr lang="fr-FR" sz="1200" b="1" u="none" strike="noStrike" dirty="0" err="1">
+                          <a:effectLst/>
+                        </a:rPr>
+                        <a:t>Ultra-Simple</a:t>
+                      </a:r>
+                      <a:r>
+                        <a:rPr lang="fr-FR" sz="1200" b="1" u="none" strike="noStrike" dirty="0">
+                          <a:effectLst/>
+                        </a:rPr>
+                        <a:t> NN</a:t>
+                      </a:r>
+                      <a:endParaRPr lang="fr-FR" sz="1200" b="1" i="0" u="none" strike="noStrike" dirty="0">
+                        <a:solidFill>
+                          <a:srgbClr val="000000"/>
+                        </a:solidFill>
+                        <a:effectLst/>
+                        <a:latin typeface="Arial" panose="020B0604020202020204" pitchFamily="34" charset="0"/>
+                      </a:endParaRPr>
+                    </a:p>
+                  </a:txBody>
+                  <a:tcPr marL="6350" marR="6350" marT="6350" marB="0" anchor="b"/>
+                </a:tc>
+                <a:tc>
+                  <a:txBody>
+                    <a:bodyPr/>
+                    <a:lstStyle/>
+                    <a:p>
+                      <a:pPr algn="r" fontAlgn="b">
+                        <a:buNone/>
+                      </a:pPr>
+                      <a:r>
+                        <a:rPr lang="fr-FR" sz="1200" u="none" strike="noStrike">
+                          <a:effectLst/>
+                        </a:rPr>
+                        <a:t>0.9892</a:t>
+                      </a:r>
+                      <a:endParaRPr lang="fr-FR" sz="1200" b="0" i="0" u="none" strike="noStrike">
+                        <a:solidFill>
+                          <a:srgbClr val="000000"/>
+                        </a:solidFill>
+                        <a:effectLst/>
+                        <a:latin typeface="Arial" panose="020B0604020202020204" pitchFamily="34" charset="0"/>
+                      </a:endParaRPr>
+                    </a:p>
+                  </a:txBody>
+                  <a:tcPr marL="6350" marR="6350" marT="6350" marB="0" anchor="b"/>
+                </a:tc>
+                <a:tc>
+                  <a:txBody>
+                    <a:bodyPr/>
+                    <a:lstStyle/>
+                    <a:p>
+                      <a:pPr algn="r" fontAlgn="b">
+                        <a:buNone/>
+                      </a:pPr>
+                      <a:r>
+                        <a:rPr lang="fr-FR" sz="1200" u="none" strike="noStrike">
+                          <a:effectLst/>
+                        </a:rPr>
+                        <a:t>0.9972</a:t>
+                      </a:r>
+                      <a:endParaRPr lang="fr-FR" sz="1200" b="0" i="0" u="none" strike="noStrike">
+                        <a:solidFill>
+                          <a:srgbClr val="000000"/>
+                        </a:solidFill>
+                        <a:effectLst/>
+                        <a:latin typeface="Arial" panose="020B0604020202020204" pitchFamily="34" charset="0"/>
+                      </a:endParaRPr>
+                    </a:p>
+                  </a:txBody>
+                  <a:tcPr marL="6350" marR="6350" marT="6350" marB="0" anchor="b"/>
+                </a:tc>
+                <a:tc>
+                  <a:txBody>
+                    <a:bodyPr/>
+                    <a:lstStyle/>
+                    <a:p>
+                      <a:pPr algn="r" fontAlgn="b">
+                        <a:buNone/>
+                      </a:pPr>
+                      <a:r>
+                        <a:rPr lang="fr-FR" sz="1200" u="none" strike="noStrike" dirty="0">
+                          <a:effectLst/>
+                        </a:rPr>
+                        <a:t>25,217</a:t>
+                      </a:r>
+                      <a:endParaRPr lang="fr-FR" sz="1200" b="0" i="0" u="none" strike="noStrike" dirty="0">
+                        <a:solidFill>
+                          <a:srgbClr val="000000"/>
+                        </a:solidFill>
+                        <a:effectLst/>
+                        <a:latin typeface="Arial" panose="020B0604020202020204" pitchFamily="34" charset="0"/>
+                      </a:endParaRPr>
+                    </a:p>
+                  </a:txBody>
+                  <a:tcPr marL="6350" marR="6350" marT="6350" marB="0" anchor="b"/>
+                </a:tc>
+                <a:extLst>
+                  <a:ext uri="{0D108BD9-81ED-4DB2-BD59-A6C34878D82A}">
+                    <a16:rowId xmlns:a16="http://schemas.microsoft.com/office/drawing/2014/main" val="679414960"/>
+                  </a:ext>
+                </a:extLst>
+              </a:tr>
+            </a:tbl>
+          </a:graphicData>
+        </a:graphic>
+      </p:graphicFrame>
+    </p:spTree>
+    <p:extLst>
+      <p:ext uri="{BB962C8B-B14F-4D97-AF65-F5344CB8AC3E}">
+        <p14:creationId xmlns:p14="http://schemas.microsoft.com/office/powerpoint/2010/main" val="2507890807"/>
       </p:ext>
     </p:extLst>
   </p:cSld>

</xml_diff>